<commit_message>
Reschedule STEP 1 to TAF end date (Sep 2027): PIN by May 2027, pipeline target Sep 2027
Co-Authored-By: Claude Opus 5.5 <noreply@anthropic.com>
Claude-Session: https://claude.ai/code/session_01Tt9bQwcKRKX4vaP5NybJqL
</commit_message>
<xml_diff>
--- a/hutan-desa-pasir/Roadmap_HD_Pasir_PVClimate.pptx
+++ b/hutan-desa-pasir/Roadmap_HD_Pasir_PVClimate.pptx
@@ -3850,7 +3850,7 @@
                 </a:solidFill>
                 <a:latin typeface="Calibri"/>
               </a:rPr>
-              <a:t>Okt 2026 – ±Apr 2028 · Dukungan: TAF · Pelaksana: SAMPAN Kalimantan &amp; LPHD Pasir</a:t>
+              <a:t>Okt 2026 – Sep 2027 · Dukungan: TAF · Pelaksana: SAMPAN Kalimantan &amp; LPHD Pasir</a:t>
             </a:r>
           </a:p>
         </p:txBody>
@@ -4545,7 +4545,7 @@
                 </a:solidFill>
                 <a:latin typeface="Calibri"/>
               </a:rPr>
-              <a:t>PIN Template V1.4</a:t>
+              <a:t>Diajukan ≤ Mei 2027</a:t>
             </a:r>
           </a:p>
           <a:p>
@@ -4557,7 +4557,7 @@
                 </a:solidFill>
                 <a:latin typeface="Calibri"/>
               </a:rPr>
-              <a:t>+ PIN review fee</a:t>
+              <a:t>(PIN Template V1.4)</a:t>
             </a:r>
           </a:p>
         </p:txBody>
@@ -4715,7 +4715,7 @@
                 </a:solidFill>
                 <a:latin typeface="Calibri"/>
               </a:rPr>
-              <a:t>PIN disetujui Plan Vivo</a:t>
+              <a:t>Target Sep 2027 — keputusan</a:t>
             </a:r>
           </a:p>
           <a:p>
@@ -4727,7 +4727,7 @@
                 </a:solidFill>
                 <a:latin typeface="Calibri"/>
               </a:rPr>
-              <a:t>(bukan otomatis)</a:t>
+              <a:t>Plan Vivo, bukan otomatis</a:t>
             </a:r>
           </a:p>
         </p:txBody>
@@ -5039,7 +5039,7 @@
                 </a:solidFill>
                 <a:latin typeface="Calibri"/>
               </a:rPr>
-              <a:t>2028 → · Dukungan: pendanaan lanjutan</a:t>
+              <a:t>Q4 2027 → · Dukungan: pendanaan lanjutan</a:t>
             </a:r>
           </a:p>
         </p:txBody>
@@ -6480,7 +6480,7 @@
                 </a:solidFill>
                 <a:latin typeface="Calibri"/>
               </a:rPr>
-              <a:t>Persiapan → PIN → Pipeline · SAMPAN Kalimantan &amp; LPHD Pasir · Okt 2026 – ±Apr 2028</a:t>
+              <a:t>Persiapan → PIN → Pipeline · SAMPAN Kalimantan &amp; LPHD Pasir · Okt 2026 – Sep 2027</a:t>
             </a:r>
           </a:p>
         </p:txBody>
@@ -6558,7 +6558,7 @@
                 </a:solidFill>
                 <a:latin typeface="Calibri"/>
               </a:rPr>
-              <a:t>PDD → kredit → penjualan · 2028+ (indikatif)</a:t>
+              <a:t>PDD → kredit → penjualan · Q4 2027+ (indikatif)</a:t>
             </a:r>
           </a:p>
         </p:txBody>
@@ -6738,7 +6738,7 @@
                 </a:solidFill>
                 <a:latin typeface="Calibri"/>
               </a:rPr>
-              <a:t>Okt 26–Des 26</a:t>
+              <a:t>Okt 26–Nov 26</a:t>
             </a:r>
           </a:p>
         </p:txBody>
@@ -6906,7 +6906,7 @@
                 </a:solidFill>
                 <a:latin typeface="Calibri"/>
               </a:rPr>
-              <a:t>Nov 26–Jan 27</a:t>
+              <a:t>Nov 26–Des 26</a:t>
             </a:r>
           </a:p>
         </p:txBody>
@@ -7074,7 +7074,7 @@
                 </a:solidFill>
                 <a:latin typeface="Calibri"/>
               </a:rPr>
-              <a:t>Jan 27–Jul 27</a:t>
+              <a:t>Des 26–Apr 27</a:t>
             </a:r>
           </a:p>
         </p:txBody>
@@ -7242,7 +7242,7 @@
                 </a:solidFill>
                 <a:latin typeface="Calibri"/>
               </a:rPr>
-              <a:t>Mar 27–Sep 27</a:t>
+              <a:t>Jan 27–Jul 27</a:t>
             </a:r>
           </a:p>
         </p:txBody>
@@ -7410,7 +7410,7 @@
                 </a:solidFill>
                 <a:latin typeface="Calibri"/>
               </a:rPr>
-              <a:t>Feb 27–Agu 27</a:t>
+              <a:t>Des 26–Apr 27</a:t>
             </a:r>
           </a:p>
         </p:txBody>
@@ -7578,7 +7578,7 @@
                 </a:solidFill>
                 <a:latin typeface="Calibri"/>
               </a:rPr>
-              <a:t>Agu 27–Nov 27</a:t>
+              <a:t>Mar 27–Mei 27</a:t>
             </a:r>
           </a:p>
         </p:txBody>
@@ -7746,7 +7746,7 @@
                 </a:solidFill>
                 <a:latin typeface="Calibri"/>
               </a:rPr>
-              <a:t>Nov 27–Apr 28</a:t>
+              <a:t>Mei 27–Sep 27</a:t>
             </a:r>
           </a:p>
         </p:txBody>
@@ -7916,7 +7916,7 @@
                 </a:solidFill>
                 <a:latin typeface="Calibri"/>
               </a:rPr>
-              <a:t>2028–2029</a:t>
+              <a:t>2027–2029</a:t>
             </a:r>
           </a:p>
         </p:txBody>
@@ -8809,7 +8809,7 @@
         <p:spPr>
           <a:xfrm>
             <a:off x="777240" y="3767328"/>
-            <a:ext cx="1025090" cy="100584"/>
+            <a:ext cx="865632" cy="100584"/>
           </a:xfrm>
           <a:prstGeom prst="rect">
             <a:avLst/>
@@ -8873,8 +8873,8 @@
         </p:nvSpPr>
         <p:spPr>
           <a:xfrm>
-            <a:off x="1118936" y="3922776"/>
-            <a:ext cx="1025090" cy="100584"/>
+            <a:off x="1210056" y="3922776"/>
+            <a:ext cx="865632" cy="100584"/>
           </a:xfrm>
           <a:prstGeom prst="rect">
             <a:avLst/>
@@ -8938,8 +8938,8 @@
         </p:nvSpPr>
         <p:spPr>
           <a:xfrm>
-            <a:off x="1802330" y="4078224"/>
-            <a:ext cx="2391877" cy="100584"/>
+            <a:off x="1642872" y="4078224"/>
+            <a:ext cx="2164079" cy="100584"/>
           </a:xfrm>
           <a:prstGeom prst="rect">
             <a:avLst/>
@@ -9003,8 +9003,8 @@
         </p:nvSpPr>
         <p:spPr>
           <a:xfrm>
-            <a:off x="2485724" y="4233672"/>
-            <a:ext cx="2391877" cy="100584"/>
+            <a:off x="2075688" y="4233672"/>
+            <a:ext cx="3029711" cy="100584"/>
           </a:xfrm>
           <a:prstGeom prst="rect">
             <a:avLst/>
@@ -9068,8 +9068,8 @@
         </p:nvSpPr>
         <p:spPr>
           <a:xfrm>
-            <a:off x="2144027" y="4389120"/>
-            <a:ext cx="2391877" cy="100584"/>
+            <a:off x="1642872" y="4389120"/>
+            <a:ext cx="2164079" cy="100584"/>
           </a:xfrm>
           <a:prstGeom prst="rect">
             <a:avLst/>
@@ -9133,8 +9133,8 @@
         </p:nvSpPr>
         <p:spPr>
           <a:xfrm>
-            <a:off x="4194208" y="4544568"/>
-            <a:ext cx="1366787" cy="100584"/>
+            <a:off x="2941320" y="4544568"/>
+            <a:ext cx="1298448" cy="100584"/>
           </a:xfrm>
           <a:prstGeom prst="rect">
             <a:avLst/>
@@ -9198,8 +9198,8 @@
         </p:nvSpPr>
         <p:spPr>
           <a:xfrm>
-            <a:off x="5219298" y="4700016"/>
-            <a:ext cx="2050181" cy="100584"/>
+            <a:off x="3806952" y="4700016"/>
+            <a:ext cx="2164080" cy="100584"/>
           </a:xfrm>
           <a:prstGeom prst="rect">
             <a:avLst/>
@@ -9263,7 +9263,7 @@
         </p:nvSpPr>
         <p:spPr>
           <a:xfrm>
-            <a:off x="1528010" y="4855464"/>
+            <a:off x="1801368" y="4855464"/>
             <a:ext cx="548640" cy="164592"/>
           </a:xfrm>
           <a:prstGeom prst="rect">
@@ -9298,7 +9298,7 @@
         </p:nvSpPr>
         <p:spPr>
           <a:xfrm>
-            <a:off x="2553101" y="4855464"/>
+            <a:off x="3099816" y="4855464"/>
             <a:ext cx="548640" cy="164592"/>
           </a:xfrm>
           <a:prstGeom prst="rect">
@@ -9333,7 +9333,7 @@
         </p:nvSpPr>
         <p:spPr>
           <a:xfrm>
-            <a:off x="3578191" y="4855464"/>
+            <a:off x="4398264" y="4855464"/>
             <a:ext cx="548640" cy="164592"/>
           </a:xfrm>
           <a:prstGeom prst="rect">
@@ -9368,7 +9368,7 @@
         </p:nvSpPr>
         <p:spPr>
           <a:xfrm>
-            <a:off x="4603282" y="4855464"/>
+            <a:off x="5696712" y="4855464"/>
             <a:ext cx="548640" cy="164592"/>
           </a:xfrm>
           <a:prstGeom prst="rect">
@@ -9395,41 +9395,41 @@
           </a:p>
         </p:txBody>
       </p:sp>
-      <p:sp>
-        <p:nvSpPr>
-          <p:cNvPr id="81" name="TextBox 80"/>
-          <p:cNvSpPr txBox="1"/>
-          <p:nvPr/>
-        </p:nvSpPr>
-        <p:spPr>
-          <a:xfrm>
-            <a:off x="5628372" y="4855464"/>
-            <a:ext cx="548640" cy="164592"/>
-          </a:xfrm>
-          <a:prstGeom prst="rect">
-            <a:avLst/>
-          </a:prstGeom>
-          <a:noFill/>
-        </p:spPr>
-        <p:txBody>
-          <a:bodyPr wrap="square" lIns="18288" rIns="18288" tIns="9144" bIns="9144" anchor="t">
-            <a:spAutoFit/>
-          </a:bodyPr>
-          <a:lstStyle/>
-          <a:p>
-            <a:pPr algn="ctr"/>
-            <a:r>
-              <a:rPr sz="650" b="0" i="0">
-                <a:solidFill>
-                  <a:srgbClr val="5F6B65"/>
-                </a:solidFill>
-                <a:latin typeface="Calibri"/>
-              </a:rPr>
-              <a:t>Jan 28</a:t>
-            </a:r>
-          </a:p>
-        </p:txBody>
-      </p:sp>
+      <p:cxnSp>
+        <p:nvCxnSpPr>
+          <p:cNvPr id="81" name="Connector 80"/>
+          <p:cNvCxnSpPr/>
+          <p:nvPr/>
+        </p:nvCxnSpPr>
+        <p:spPr>
+          <a:xfrm>
+            <a:off x="5971032" y="3721608"/>
+            <a:ext cx="0" cy="1133856"/>
+          </a:xfrm>
+          <a:prstGeom prst="line">
+            <a:avLst/>
+          </a:prstGeom>
+          <a:ln w="15875">
+            <a:solidFill>
+              <a:srgbClr val="C26A0A"/>
+            </a:solidFill>
+          </a:ln>
+        </p:spPr>
+        <p:style>
+          <a:lnRef idx="2">
+            <a:schemeClr val="accent1"/>
+          </a:lnRef>
+          <a:fillRef idx="0">
+            <a:schemeClr val="accent1"/>
+          </a:fillRef>
+          <a:effectRef idx="1">
+            <a:schemeClr val="accent1"/>
+          </a:effectRef>
+          <a:fontRef idx="minor">
+            <a:schemeClr val="tx1"/>
+          </a:fontRef>
+        </p:style>
+      </p:cxnSp>
       <p:sp>
         <p:nvSpPr>
           <p:cNvPr id="82" name="TextBox 81"/>
@@ -9438,43 +9438,90 @@
         </p:nvSpPr>
         <p:spPr>
           <a:xfrm>
-            <a:off x="6653463" y="4855464"/>
-            <a:ext cx="548640" cy="164592"/>
-          </a:xfrm>
-          <a:prstGeom prst="rect">
-            <a:avLst/>
-          </a:prstGeom>
-          <a:noFill/>
-        </p:spPr>
-        <p:txBody>
-          <a:bodyPr wrap="square" lIns="18288" rIns="18288" tIns="9144" bIns="9144" anchor="t">
-            <a:spAutoFit/>
-          </a:bodyPr>
-          <a:lstStyle/>
-          <a:p>
-            <a:pPr algn="ctr"/>
-            <a:r>
-              <a:rPr sz="650" b="0" i="0">
-                <a:solidFill>
-                  <a:srgbClr val="5F6B65"/>
-                </a:solidFill>
-                <a:latin typeface="Calibri"/>
-              </a:rPr>
-              <a:t>Apr 28</a:t>
-            </a:r>
-          </a:p>
-        </p:txBody>
-      </p:sp>
-      <p:sp>
-        <p:nvSpPr>
-          <p:cNvPr id="83" name="Rectangle 82"/>
+            <a:off x="6007608" y="3547872"/>
+            <a:ext cx="1463040" cy="182880"/>
+          </a:xfrm>
+          <a:prstGeom prst="rect">
+            <a:avLst/>
+          </a:prstGeom>
+          <a:noFill/>
+        </p:spPr>
+        <p:txBody>
+          <a:bodyPr wrap="square" lIns="18288" rIns="18288" tIns="9144" bIns="9144" anchor="t">
+            <a:spAutoFit/>
+          </a:bodyPr>
+          <a:lstStyle/>
+          <a:p>
+            <a:pPr algn="l"/>
+            <a:r>
+              <a:rPr sz="700" b="1" i="0">
+                <a:solidFill>
+                  <a:srgbClr val="C26A0A"/>
+                </a:solidFill>
+                <a:latin typeface="Calibri"/>
+              </a:rPr>
+              <a:t>Akhir TAF · Sep 27</a:t>
+            </a:r>
+          </a:p>
+        </p:txBody>
+      </p:sp>
+      <p:sp>
+        <p:nvSpPr>
+          <p:cNvPr id="83" name="TextBox 82"/>
+          <p:cNvSpPr txBox="1"/>
+          <p:nvPr/>
+        </p:nvSpPr>
+        <p:spPr>
+          <a:xfrm>
+            <a:off x="6007608" y="4526280"/>
+            <a:ext cx="914400" cy="329184"/>
+          </a:xfrm>
+          <a:prstGeom prst="rect">
+            <a:avLst/>
+          </a:prstGeom>
+          <a:noFill/>
+        </p:spPr>
+        <p:txBody>
+          <a:bodyPr wrap="square" lIns="18288" rIns="18288" tIns="9144" bIns="9144" anchor="t">
+            <a:spAutoFit/>
+          </a:bodyPr>
+          <a:lstStyle/>
+          <a:p>
+            <a:pPr algn="l"/>
+            <a:r>
+              <a:rPr sz="650" b="0" i="1">
+                <a:solidFill>
+                  <a:srgbClr val="C26A0A"/>
+                </a:solidFill>
+                <a:latin typeface="Calibri"/>
+              </a:rPr>
+              <a:t>buffer review</a:t>
+            </a:r>
+          </a:p>
+          <a:p>
+            <a:pPr algn="l"/>
+            <a:r>
+              <a:rPr sz="650" b="0" i="1">
+                <a:solidFill>
+                  <a:srgbClr val="C26A0A"/>
+                </a:solidFill>
+                <a:latin typeface="Calibri"/>
+              </a:rPr>
+              <a:t>di luar TAF</a:t>
+            </a:r>
+          </a:p>
+        </p:txBody>
+      </p:sp>
+      <p:sp>
+        <p:nvSpPr>
+          <p:cNvPr id="84" name="Rectangle 83"/>
           <p:cNvSpPr/>
           <p:nvPr/>
         </p:nvSpPr>
         <p:spPr>
           <a:xfrm>
-            <a:off x="1802330" y="4046220"/>
-            <a:ext cx="3075271" cy="466344"/>
+            <a:off x="1642872" y="4046220"/>
+            <a:ext cx="3462527" cy="466344"/>
           </a:xfrm>
           <a:prstGeom prst="rect">
             <a:avLst/>
@@ -9498,14 +9545,14 @@
       </p:sp>
       <p:sp>
         <p:nvSpPr>
-          <p:cNvPr id="84" name="TextBox 83"/>
-          <p:cNvSpPr txBox="1"/>
-          <p:nvPr/>
-        </p:nvSpPr>
-        <p:spPr>
-          <a:xfrm>
-            <a:off x="4923322" y="4059936"/>
-            <a:ext cx="1737360" cy="457200"/>
+          <p:cNvPr id="85" name="TextBox 84"/>
+          <p:cNvSpPr txBox="1"/>
+          <p:nvPr/>
+        </p:nvSpPr>
+        <p:spPr>
+          <a:xfrm>
+            <a:off x="1688592" y="5010912"/>
+            <a:ext cx="3200400" cy="182880"/>
           </a:xfrm>
           <a:prstGeom prst="rect">
             <a:avLst/>
@@ -9526,26 +9573,14 @@
                 </a:solidFill>
                 <a:latin typeface="Calibri"/>
               </a:rPr>
-              <a:t>∥ M3 · M4 · M5 berjalan paralel</a:t>
-            </a:r>
-          </a:p>
-          <a:p>
-            <a:pPr algn="l"/>
-            <a:r>
-              <a:rPr sz="750" b="1" i="0">
-                <a:solidFill>
-                  <a:srgbClr val="0E7C6B"/>
-                </a:solidFill>
-                <a:latin typeface="Calibri"/>
-              </a:rPr>
-              <a:t>(bulan 4–12)</a:t>
-            </a:r>
-          </a:p>
-        </p:txBody>
-      </p:sp>
-      <p:sp>
-        <p:nvSpPr>
-          <p:cNvPr id="85" name="TextBox 84"/>
+              <a:t>∥ M3 · M4 · M5 berjalan paralel (bulan 3–10)</a:t>
+            </a:r>
+          </a:p>
+        </p:txBody>
+      </p:sp>
+      <p:sp>
+        <p:nvSpPr>
+          <p:cNvPr id="86" name="TextBox 85"/>
           <p:cNvSpPr txBox="1"/>
           <p:nvPr/>
         </p:nvSpPr>
@@ -9580,7 +9615,7 @@
       </p:sp>
       <p:sp>
         <p:nvSpPr>
-          <p:cNvPr id="86" name="TextBox 85"/>
+          <p:cNvPr id="87" name="TextBox 86"/>
           <p:cNvSpPr txBox="1"/>
           <p:nvPr/>
         </p:nvSpPr>
@@ -9615,14 +9650,14 @@
       </p:sp>
       <p:sp>
         <p:nvSpPr>
-          <p:cNvPr id="87" name="Rectangle 86"/>
+          <p:cNvPr id="88" name="Rectangle 87"/>
           <p:cNvSpPr/>
           <p:nvPr/>
         </p:nvSpPr>
         <p:spPr>
           <a:xfrm>
-            <a:off x="7902244" y="3767328"/>
-            <a:ext cx="877823" cy="100584"/>
+            <a:off x="7909307" y="3767328"/>
+            <a:ext cx="869752" cy="100584"/>
           </a:xfrm>
           <a:prstGeom prst="rect">
             <a:avLst/>
@@ -9645,7 +9680,7 @@
       </p:sp>
       <p:sp>
         <p:nvSpPr>
-          <p:cNvPr id="88" name="TextBox 87"/>
+          <p:cNvPr id="89" name="TextBox 88"/>
           <p:cNvSpPr txBox="1"/>
           <p:nvPr/>
         </p:nvSpPr>
@@ -9680,14 +9715,14 @@
       </p:sp>
       <p:sp>
         <p:nvSpPr>
-          <p:cNvPr id="89" name="Rectangle 88"/>
+          <p:cNvPr id="90" name="Rectangle 89"/>
           <p:cNvSpPr/>
           <p:nvPr/>
         </p:nvSpPr>
         <p:spPr>
           <a:xfrm>
-            <a:off x="8663025" y="3922776"/>
-            <a:ext cx="585215" cy="100584"/>
+            <a:off x="8670340" y="3922776"/>
+            <a:ext cx="543595" cy="100584"/>
           </a:xfrm>
           <a:prstGeom prst="rect">
             <a:avLst/>
@@ -9710,7 +9745,7 @@
       </p:sp>
       <p:sp>
         <p:nvSpPr>
-          <p:cNvPr id="90" name="TextBox 89"/>
+          <p:cNvPr id="91" name="TextBox 90"/>
           <p:cNvSpPr txBox="1"/>
           <p:nvPr/>
         </p:nvSpPr>
@@ -9745,14 +9780,14 @@
       </p:sp>
       <p:sp>
         <p:nvSpPr>
-          <p:cNvPr id="91" name="Rectangle 90"/>
+          <p:cNvPr id="92" name="Rectangle 91"/>
           <p:cNvSpPr/>
           <p:nvPr/>
         </p:nvSpPr>
         <p:spPr>
           <a:xfrm>
-            <a:off x="9189719" y="4078224"/>
-            <a:ext cx="2633472" cy="100584"/>
+            <a:off x="9159576" y="4078224"/>
+            <a:ext cx="2663615" cy="100584"/>
           </a:xfrm>
           <a:prstGeom prst="rect">
             <a:avLst/>
@@ -9775,7 +9810,7 @@
       </p:sp>
       <p:sp>
         <p:nvSpPr>
-          <p:cNvPr id="92" name="TextBox 91"/>
+          <p:cNvPr id="93" name="TextBox 92"/>
           <p:cNvSpPr txBox="1"/>
           <p:nvPr/>
         </p:nvSpPr>
@@ -9810,14 +9845,14 @@
       </p:sp>
       <p:sp>
         <p:nvSpPr>
-          <p:cNvPr id="93" name="Rectangle 92"/>
+          <p:cNvPr id="94" name="Rectangle 93"/>
           <p:cNvSpPr/>
           <p:nvPr/>
         </p:nvSpPr>
         <p:spPr>
           <a:xfrm>
-            <a:off x="10067544" y="4233672"/>
-            <a:ext cx="409651" cy="100584"/>
+            <a:off x="10029328" y="4233672"/>
+            <a:ext cx="380516" cy="100584"/>
           </a:xfrm>
           <a:prstGeom prst="rect">
             <a:avLst/>
@@ -9840,7 +9875,7 @@
       </p:sp>
       <p:sp>
         <p:nvSpPr>
-          <p:cNvPr id="94" name="TextBox 93"/>
+          <p:cNvPr id="95" name="TextBox 94"/>
           <p:cNvSpPr txBox="1"/>
           <p:nvPr/>
         </p:nvSpPr>
@@ -9875,14 +9910,14 @@
       </p:sp>
       <p:sp>
         <p:nvSpPr>
-          <p:cNvPr id="95" name="Rectangle 94"/>
+          <p:cNvPr id="96" name="Rectangle 95"/>
           <p:cNvSpPr/>
           <p:nvPr/>
         </p:nvSpPr>
         <p:spPr>
           <a:xfrm>
-            <a:off x="8077809" y="4389120"/>
-            <a:ext cx="3745382" cy="100584"/>
+            <a:off x="8126745" y="4389120"/>
+            <a:ext cx="3696446" cy="100584"/>
           </a:xfrm>
           <a:prstGeom prst="rect">
             <a:avLst/>
@@ -9907,14 +9942,14 @@
       </p:sp>
       <p:sp>
         <p:nvSpPr>
-          <p:cNvPr id="96" name="Rectangle 95"/>
+          <p:cNvPr id="97" name="Rectangle 96"/>
           <p:cNvSpPr/>
           <p:nvPr/>
         </p:nvSpPr>
         <p:spPr>
           <a:xfrm>
-            <a:off x="11472062" y="4233672"/>
-            <a:ext cx="351129" cy="100584"/>
+            <a:off x="11497034" y="4233672"/>
+            <a:ext cx="326157" cy="100584"/>
           </a:xfrm>
           <a:prstGeom prst="rect">
             <a:avLst/>
@@ -9938,13 +9973,13 @@
       </p:sp>
       <p:sp>
         <p:nvSpPr>
-          <p:cNvPr id="97" name="TextBox 96"/>
-          <p:cNvSpPr txBox="1"/>
-          <p:nvPr/>
-        </p:nvSpPr>
-        <p:spPr>
-          <a:xfrm>
-            <a:off x="7498079" y="4562856"/>
+          <p:cNvPr id="98" name="TextBox 97"/>
+          <p:cNvSpPr txBox="1"/>
+          <p:nvPr/>
+        </p:nvSpPr>
+        <p:spPr>
+          <a:xfrm>
+            <a:off x="7789426" y="4562856"/>
             <a:ext cx="457200" cy="164592"/>
           </a:xfrm>
           <a:prstGeom prst="rect">
@@ -9973,13 +10008,13 @@
       </p:sp>
       <p:sp>
         <p:nvSpPr>
-          <p:cNvPr id="98" name="TextBox 97"/>
-          <p:cNvSpPr txBox="1"/>
-          <p:nvPr/>
-        </p:nvSpPr>
-        <p:spPr>
-          <a:xfrm>
-            <a:off x="8083296" y="4562856"/>
+          <p:cNvPr id="99" name="TextBox 98"/>
+          <p:cNvSpPr txBox="1"/>
+          <p:nvPr/>
+        </p:nvSpPr>
+        <p:spPr>
+          <a:xfrm>
+            <a:off x="8333021" y="4562856"/>
             <a:ext cx="457200" cy="164592"/>
           </a:xfrm>
           <a:prstGeom prst="rect">
@@ -10008,13 +10043,13 @@
       </p:sp>
       <p:sp>
         <p:nvSpPr>
-          <p:cNvPr id="99" name="TextBox 98"/>
-          <p:cNvSpPr txBox="1"/>
-          <p:nvPr/>
-        </p:nvSpPr>
-        <p:spPr>
-          <a:xfrm>
-            <a:off x="8668511" y="4562856"/>
+          <p:cNvPr id="100" name="TextBox 99"/>
+          <p:cNvSpPr txBox="1"/>
+          <p:nvPr/>
+        </p:nvSpPr>
+        <p:spPr>
+          <a:xfrm>
+            <a:off x="8876616" y="4562856"/>
             <a:ext cx="457200" cy="164592"/>
           </a:xfrm>
           <a:prstGeom prst="rect">
@@ -10043,13 +10078,13 @@
       </p:sp>
       <p:sp>
         <p:nvSpPr>
-          <p:cNvPr id="100" name="TextBox 99"/>
-          <p:cNvSpPr txBox="1"/>
-          <p:nvPr/>
-        </p:nvSpPr>
-        <p:spPr>
-          <a:xfrm>
-            <a:off x="9253728" y="4562856"/>
+          <p:cNvPr id="101" name="TextBox 100"/>
+          <p:cNvSpPr txBox="1"/>
+          <p:nvPr/>
+        </p:nvSpPr>
+        <p:spPr>
+          <a:xfrm>
+            <a:off x="9420211" y="4562856"/>
             <a:ext cx="457200" cy="164592"/>
           </a:xfrm>
           <a:prstGeom prst="rect">
@@ -10078,13 +10113,13 @@
       </p:sp>
       <p:sp>
         <p:nvSpPr>
-          <p:cNvPr id="101" name="TextBox 100"/>
-          <p:cNvSpPr txBox="1"/>
-          <p:nvPr/>
-        </p:nvSpPr>
-        <p:spPr>
-          <a:xfrm>
-            <a:off x="9838944" y="4562856"/>
+          <p:cNvPr id="102" name="TextBox 101"/>
+          <p:cNvSpPr txBox="1"/>
+          <p:nvPr/>
+        </p:nvSpPr>
+        <p:spPr>
+          <a:xfrm>
+            <a:off x="9963806" y="4562856"/>
             <a:ext cx="457200" cy="164592"/>
           </a:xfrm>
           <a:prstGeom prst="rect">
@@ -10113,13 +10148,13 @@
       </p:sp>
       <p:sp>
         <p:nvSpPr>
-          <p:cNvPr id="102" name="TextBox 101"/>
-          <p:cNvSpPr txBox="1"/>
-          <p:nvPr/>
-        </p:nvSpPr>
-        <p:spPr>
-          <a:xfrm>
-            <a:off x="10424159" y="4562856"/>
+          <p:cNvPr id="103" name="TextBox 102"/>
+          <p:cNvSpPr txBox="1"/>
+          <p:nvPr/>
+        </p:nvSpPr>
+        <p:spPr>
+          <a:xfrm>
+            <a:off x="10507401" y="4562856"/>
             <a:ext cx="457200" cy="164592"/>
           </a:xfrm>
           <a:prstGeom prst="rect">
@@ -10148,13 +10183,13 @@
       </p:sp>
       <p:sp>
         <p:nvSpPr>
-          <p:cNvPr id="103" name="TextBox 102"/>
-          <p:cNvSpPr txBox="1"/>
-          <p:nvPr/>
-        </p:nvSpPr>
-        <p:spPr>
-          <a:xfrm>
-            <a:off x="11009376" y="4562856"/>
+          <p:cNvPr id="104" name="TextBox 103"/>
+          <p:cNvSpPr txBox="1"/>
+          <p:nvPr/>
+        </p:nvSpPr>
+        <p:spPr>
+          <a:xfrm>
+            <a:off x="11050996" y="4562856"/>
             <a:ext cx="457200" cy="164592"/>
           </a:xfrm>
           <a:prstGeom prst="rect">
@@ -10177,41 +10212,6 @@
                 <a:latin typeface="Calibri"/>
               </a:rPr>
               <a:t>2034</a:t>
-            </a:r>
-          </a:p>
-        </p:txBody>
-      </p:sp>
-      <p:sp>
-        <p:nvSpPr>
-          <p:cNvPr id="104" name="TextBox 103"/>
-          <p:cNvSpPr txBox="1"/>
-          <p:nvPr/>
-        </p:nvSpPr>
-        <p:spPr>
-          <a:xfrm>
-            <a:off x="11594592" y="4562856"/>
-            <a:ext cx="457200" cy="164592"/>
-          </a:xfrm>
-          <a:prstGeom prst="rect">
-            <a:avLst/>
-          </a:prstGeom>
-          <a:noFill/>
-        </p:spPr>
-        <p:txBody>
-          <a:bodyPr wrap="square" lIns="18288" rIns="18288" tIns="9144" bIns="9144" anchor="t">
-            <a:spAutoFit/>
-          </a:bodyPr>
-          <a:lstStyle/>
-          <a:p>
-            <a:pPr algn="ctr"/>
-            <a:r>
-              <a:rPr sz="650" b="0" i="0">
-                <a:solidFill>
-                  <a:srgbClr val="5F6B65"/>
-                </a:solidFill>
-                <a:latin typeface="Calibri"/>
-              </a:rPr>
-              <a:t/>
             </a:r>
           </a:p>
         </p:txBody>
@@ -10860,7 +10860,7 @@
                 </a:solidFill>
                 <a:latin typeface="Cambria"/>
               </a:rPr>
-              <a:t>Jalur kritis melewati FPIC dan keputusan metodologi —</a:t>
+              <a:t>PIN harus dikirim Mei 2027 agar keputusan Plan Vivo dapat</a:t>
             </a:r>
           </a:p>
           <a:p>
@@ -10872,7 +10872,7 @@
                 </a:solidFill>
                 <a:latin typeface="Cambria"/>
               </a:rPr>
-              <a:t>PIN dikirim paling lambat bulan ke-14 (Nov 2027)</a:t>
+              <a:t>keluar sebelum TAF berakhir September 2027</a:t>
             </a:r>
           </a:p>
         </p:txBody>
@@ -10921,7 +10921,7 @@
         <p:spPr>
           <a:xfrm>
             <a:off x="3063240" y="1371600"/>
-            <a:ext cx="451906" cy="329184"/>
+            <a:ext cx="574852" cy="329184"/>
           </a:xfrm>
           <a:prstGeom prst="rect">
             <a:avLst/>
@@ -10951,7 +10951,7 @@
         <p:spPr>
           <a:xfrm>
             <a:off x="3063240" y="1380744"/>
-            <a:ext cx="461050" cy="329184"/>
+            <a:ext cx="583996" cy="329184"/>
           </a:xfrm>
           <a:prstGeom prst="rect">
             <a:avLst/>
@@ -10997,8 +10997,8 @@
         </p:nvSpPr>
         <p:spPr>
           <a:xfrm>
-            <a:off x="3524290" y="1371600"/>
-            <a:ext cx="451906" cy="329184"/>
+            <a:off x="3647236" y="1371600"/>
+            <a:ext cx="574852" cy="329184"/>
           </a:xfrm>
           <a:prstGeom prst="rect">
             <a:avLst/>
@@ -11027,8 +11027,8 @@
         </p:nvSpPr>
         <p:spPr>
           <a:xfrm>
-            <a:off x="3524290" y="1380744"/>
-            <a:ext cx="461050" cy="329184"/>
+            <a:off x="3647236" y="1380744"/>
+            <a:ext cx="583996" cy="329184"/>
           </a:xfrm>
           <a:prstGeom prst="rect">
             <a:avLst/>
@@ -11074,8 +11074,8 @@
         </p:nvSpPr>
         <p:spPr>
           <a:xfrm>
-            <a:off x="3985340" y="1371600"/>
-            <a:ext cx="451906" cy="329184"/>
+            <a:off x="4231233" y="1371600"/>
+            <a:ext cx="574852" cy="329184"/>
           </a:xfrm>
           <a:prstGeom prst="rect">
             <a:avLst/>
@@ -11104,8 +11104,8 @@
         </p:nvSpPr>
         <p:spPr>
           <a:xfrm>
-            <a:off x="3985340" y="1380744"/>
-            <a:ext cx="461050" cy="329184"/>
+            <a:off x="4231233" y="1380744"/>
+            <a:ext cx="583996" cy="329184"/>
           </a:xfrm>
           <a:prstGeom prst="rect">
             <a:avLst/>
@@ -11151,8 +11151,8 @@
         </p:nvSpPr>
         <p:spPr>
           <a:xfrm>
-            <a:off x="4446390" y="1371600"/>
-            <a:ext cx="451906" cy="329184"/>
+            <a:off x="4815230" y="1371600"/>
+            <a:ext cx="574852" cy="329184"/>
           </a:xfrm>
           <a:prstGeom prst="rect">
             <a:avLst/>
@@ -11181,8 +11181,8 @@
         </p:nvSpPr>
         <p:spPr>
           <a:xfrm>
-            <a:off x="4446390" y="1380744"/>
-            <a:ext cx="461050" cy="329184"/>
+            <a:off x="4815230" y="1380744"/>
+            <a:ext cx="583996" cy="329184"/>
           </a:xfrm>
           <a:prstGeom prst="rect">
             <a:avLst/>
@@ -11228,8 +11228,8 @@
         </p:nvSpPr>
         <p:spPr>
           <a:xfrm>
-            <a:off x="4907440" y="1371600"/>
-            <a:ext cx="451906" cy="329184"/>
+            <a:off x="5399227" y="1371600"/>
+            <a:ext cx="574852" cy="329184"/>
           </a:xfrm>
           <a:prstGeom prst="rect">
             <a:avLst/>
@@ -11258,8 +11258,8 @@
         </p:nvSpPr>
         <p:spPr>
           <a:xfrm>
-            <a:off x="4907440" y="1380744"/>
-            <a:ext cx="461050" cy="329184"/>
+            <a:off x="5399227" y="1380744"/>
+            <a:ext cx="583996" cy="329184"/>
           </a:xfrm>
           <a:prstGeom prst="rect">
             <a:avLst/>
@@ -11305,8 +11305,8 @@
         </p:nvSpPr>
         <p:spPr>
           <a:xfrm>
-            <a:off x="5368490" y="1371600"/>
-            <a:ext cx="451906" cy="329184"/>
+            <a:off x="5983224" y="1371600"/>
+            <a:ext cx="574852" cy="329184"/>
           </a:xfrm>
           <a:prstGeom prst="rect">
             <a:avLst/>
@@ -11335,8 +11335,8 @@
         </p:nvSpPr>
         <p:spPr>
           <a:xfrm>
-            <a:off x="5368490" y="1380744"/>
-            <a:ext cx="461050" cy="329184"/>
+            <a:off x="5983224" y="1380744"/>
+            <a:ext cx="583996" cy="329184"/>
           </a:xfrm>
           <a:prstGeom prst="rect">
             <a:avLst/>
@@ -11382,8 +11382,8 @@
         </p:nvSpPr>
         <p:spPr>
           <a:xfrm>
-            <a:off x="5829540" y="1371600"/>
-            <a:ext cx="451906" cy="329184"/>
+            <a:off x="6567220" y="1371600"/>
+            <a:ext cx="574852" cy="329184"/>
           </a:xfrm>
           <a:prstGeom prst="rect">
             <a:avLst/>
@@ -11412,8 +11412,8 @@
         </p:nvSpPr>
         <p:spPr>
           <a:xfrm>
-            <a:off x="5829540" y="1380744"/>
-            <a:ext cx="461050" cy="329184"/>
+            <a:off x="6567220" y="1380744"/>
+            <a:ext cx="583996" cy="329184"/>
           </a:xfrm>
           <a:prstGeom prst="rect">
             <a:avLst/>
@@ -11459,8 +11459,8 @@
         </p:nvSpPr>
         <p:spPr>
           <a:xfrm>
-            <a:off x="6290590" y="1371600"/>
-            <a:ext cx="451906" cy="329184"/>
+            <a:off x="7151217" y="1371600"/>
+            <a:ext cx="574852" cy="329184"/>
           </a:xfrm>
           <a:prstGeom prst="rect">
             <a:avLst/>
@@ -11489,8 +11489,8 @@
         </p:nvSpPr>
         <p:spPr>
           <a:xfrm>
-            <a:off x="6290590" y="1380744"/>
-            <a:ext cx="461050" cy="329184"/>
+            <a:off x="7151217" y="1380744"/>
+            <a:ext cx="583996" cy="329184"/>
           </a:xfrm>
           <a:prstGeom prst="rect">
             <a:avLst/>
@@ -11536,8 +11536,8 @@
         </p:nvSpPr>
         <p:spPr>
           <a:xfrm>
-            <a:off x="6751640" y="1371600"/>
-            <a:ext cx="451906" cy="329184"/>
+            <a:off x="7735214" y="1371600"/>
+            <a:ext cx="574852" cy="329184"/>
           </a:xfrm>
           <a:prstGeom prst="rect">
             <a:avLst/>
@@ -11566,8 +11566,8 @@
         </p:nvSpPr>
         <p:spPr>
           <a:xfrm>
-            <a:off x="6751640" y="1380744"/>
-            <a:ext cx="461050" cy="329184"/>
+            <a:off x="7735214" y="1380744"/>
+            <a:ext cx="583996" cy="329184"/>
           </a:xfrm>
           <a:prstGeom prst="rect">
             <a:avLst/>
@@ -11613,8 +11613,8 @@
         </p:nvSpPr>
         <p:spPr>
           <a:xfrm>
-            <a:off x="7212690" y="1371600"/>
-            <a:ext cx="451906" cy="329184"/>
+            <a:off x="8319211" y="1371600"/>
+            <a:ext cx="574852" cy="329184"/>
           </a:xfrm>
           <a:prstGeom prst="rect">
             <a:avLst/>
@@ -11643,8 +11643,8 @@
         </p:nvSpPr>
         <p:spPr>
           <a:xfrm>
-            <a:off x="7212690" y="1380744"/>
-            <a:ext cx="461050" cy="329184"/>
+            <a:off x="8319211" y="1380744"/>
+            <a:ext cx="583996" cy="329184"/>
           </a:xfrm>
           <a:prstGeom prst="rect">
             <a:avLst/>
@@ -11690,8 +11690,8 @@
         </p:nvSpPr>
         <p:spPr>
           <a:xfrm>
-            <a:off x="7673741" y="1371600"/>
-            <a:ext cx="451906" cy="329184"/>
+            <a:off x="8903208" y="1371600"/>
+            <a:ext cx="574852" cy="329184"/>
           </a:xfrm>
           <a:prstGeom prst="rect">
             <a:avLst/>
@@ -11720,8 +11720,8 @@
         </p:nvSpPr>
         <p:spPr>
           <a:xfrm>
-            <a:off x="7673741" y="1380744"/>
-            <a:ext cx="461050" cy="329184"/>
+            <a:off x="8903208" y="1380744"/>
+            <a:ext cx="583996" cy="329184"/>
           </a:xfrm>
           <a:prstGeom prst="rect">
             <a:avLst/>
@@ -11767,8 +11767,8 @@
         </p:nvSpPr>
         <p:spPr>
           <a:xfrm>
-            <a:off x="8134791" y="1371600"/>
-            <a:ext cx="451906" cy="329184"/>
+            <a:off x="9487204" y="1371600"/>
+            <a:ext cx="574852" cy="329184"/>
           </a:xfrm>
           <a:prstGeom prst="rect">
             <a:avLst/>
@@ -11797,8 +11797,8 @@
         </p:nvSpPr>
         <p:spPr>
           <a:xfrm>
-            <a:off x="8134791" y="1380744"/>
-            <a:ext cx="461050" cy="329184"/>
+            <a:off x="9487204" y="1380744"/>
+            <a:ext cx="583996" cy="329184"/>
           </a:xfrm>
           <a:prstGeom prst="rect">
             <a:avLst/>
@@ -11844,162 +11844,8 @@
         </p:nvSpPr>
         <p:spPr>
           <a:xfrm>
-            <a:off x="8595841" y="1371600"/>
-            <a:ext cx="451906" cy="329184"/>
-          </a:xfrm>
-          <a:prstGeom prst="rect">
-            <a:avLst/>
-          </a:prstGeom>
-          <a:solidFill>
-            <a:srgbClr val="E3F1EE"/>
-          </a:solidFill>
-          <a:ln>
-            <a:noFill/>
-          </a:ln>
-          <a:effectLst/>
-        </p:spPr>
-        <p:txBody>
-          <a:bodyPr rtlCol="0" anchor="ctr"/>
-          <a:lstStyle/>
-          <a:p>
-            <a:pPr algn="ctr"/>
-          </a:p>
-        </p:txBody>
-      </p:sp>
-      <p:sp>
-        <p:nvSpPr>
-          <p:cNvPr id="30" name="TextBox 29"/>
-          <p:cNvSpPr txBox="1"/>
-          <p:nvPr/>
-        </p:nvSpPr>
-        <p:spPr>
-          <a:xfrm>
-            <a:off x="8595841" y="1380744"/>
-            <a:ext cx="461050" cy="329184"/>
-          </a:xfrm>
-          <a:prstGeom prst="rect">
-            <a:avLst/>
-          </a:prstGeom>
-          <a:noFill/>
-        </p:spPr>
-        <p:txBody>
-          <a:bodyPr wrap="square" lIns="18288" rIns="18288" tIns="9144" bIns="9144" anchor="t">
-            <a:spAutoFit/>
-          </a:bodyPr>
-          <a:lstStyle/>
-          <a:p>
-            <a:pPr algn="ctr"/>
-            <a:r>
-              <a:rPr sz="650" b="0" i="0">
-                <a:solidFill>
-                  <a:srgbClr val="5F6B65"/>
-                </a:solidFill>
-                <a:latin typeface="Calibri"/>
-              </a:rPr>
-              <a:t>Okt</a:t>
-            </a:r>
-          </a:p>
-          <a:p>
-            <a:pPr algn="ctr"/>
-            <a:r>
-              <a:rPr sz="650" b="0" i="0">
-                <a:solidFill>
-                  <a:srgbClr val="5F6B65"/>
-                </a:solidFill>
-                <a:latin typeface="Calibri"/>
-              </a:rPr>
-              <a:t>27</a:t>
-            </a:r>
-          </a:p>
-        </p:txBody>
-      </p:sp>
-      <p:sp>
-        <p:nvSpPr>
-          <p:cNvPr id="31" name="Rectangle 30"/>
-          <p:cNvSpPr/>
-          <p:nvPr/>
-        </p:nvSpPr>
-        <p:spPr>
-          <a:xfrm>
-            <a:off x="9056891" y="1371600"/>
-            <a:ext cx="451906" cy="329184"/>
-          </a:xfrm>
-          <a:prstGeom prst="rect">
-            <a:avLst/>
-          </a:prstGeom>
-          <a:solidFill>
-            <a:srgbClr val="E3F1EE"/>
-          </a:solidFill>
-          <a:ln>
-            <a:noFill/>
-          </a:ln>
-          <a:effectLst/>
-        </p:spPr>
-        <p:txBody>
-          <a:bodyPr rtlCol="0" anchor="ctr"/>
-          <a:lstStyle/>
-          <a:p>
-            <a:pPr algn="ctr"/>
-          </a:p>
-        </p:txBody>
-      </p:sp>
-      <p:sp>
-        <p:nvSpPr>
-          <p:cNvPr id="32" name="TextBox 31"/>
-          <p:cNvSpPr txBox="1"/>
-          <p:nvPr/>
-        </p:nvSpPr>
-        <p:spPr>
-          <a:xfrm>
-            <a:off x="9056891" y="1380744"/>
-            <a:ext cx="461050" cy="329184"/>
-          </a:xfrm>
-          <a:prstGeom prst="rect">
-            <a:avLst/>
-          </a:prstGeom>
-          <a:noFill/>
-        </p:spPr>
-        <p:txBody>
-          <a:bodyPr wrap="square" lIns="18288" rIns="18288" tIns="9144" bIns="9144" anchor="t">
-            <a:spAutoFit/>
-          </a:bodyPr>
-          <a:lstStyle/>
-          <a:p>
-            <a:pPr algn="ctr"/>
-            <a:r>
-              <a:rPr sz="650" b="0" i="0">
-                <a:solidFill>
-                  <a:srgbClr val="5F6B65"/>
-                </a:solidFill>
-                <a:latin typeface="Calibri"/>
-              </a:rPr>
-              <a:t>Nov</a:t>
-            </a:r>
-          </a:p>
-          <a:p>
-            <a:pPr algn="ctr"/>
-            <a:r>
-              <a:rPr sz="650" b="0" i="0">
-                <a:solidFill>
-                  <a:srgbClr val="5F6B65"/>
-                </a:solidFill>
-                <a:latin typeface="Calibri"/>
-              </a:rPr>
-              <a:t>27</a:t>
-            </a:r>
-          </a:p>
-        </p:txBody>
-      </p:sp>
-      <p:sp>
-        <p:nvSpPr>
-          <p:cNvPr id="33" name="Rectangle 32"/>
-          <p:cNvSpPr/>
-          <p:nvPr/>
-        </p:nvSpPr>
-        <p:spPr>
-          <a:xfrm>
-            <a:off x="9517941" y="1371600"/>
-            <a:ext cx="451906" cy="329184"/>
+            <a:off x="10071201" y="1371600"/>
+            <a:ext cx="574852" cy="329184"/>
           </a:xfrm>
           <a:prstGeom prst="rect">
             <a:avLst/>
@@ -12022,14 +11868,14 @@
       </p:sp>
       <p:sp>
         <p:nvSpPr>
-          <p:cNvPr id="34" name="TextBox 33"/>
-          <p:cNvSpPr txBox="1"/>
-          <p:nvPr/>
-        </p:nvSpPr>
-        <p:spPr>
-          <a:xfrm>
-            <a:off x="9517941" y="1380744"/>
-            <a:ext cx="461050" cy="329184"/>
+          <p:cNvPr id="30" name="TextBox 29"/>
+          <p:cNvSpPr txBox="1"/>
+          <p:nvPr/>
+        </p:nvSpPr>
+        <p:spPr>
+          <a:xfrm>
+            <a:off x="10071201" y="1380744"/>
+            <a:ext cx="583996" cy="329184"/>
           </a:xfrm>
           <a:prstGeom prst="rect">
             <a:avLst/>
@@ -12050,7 +11896,7 @@
                 </a:solidFill>
                 <a:latin typeface="Calibri"/>
               </a:rPr>
-              <a:t>Des</a:t>
+              <a:t>Okt</a:t>
             </a:r>
           </a:p>
           <a:p>
@@ -12069,14 +11915,14 @@
       </p:sp>
       <p:sp>
         <p:nvSpPr>
-          <p:cNvPr id="35" name="Rectangle 34"/>
+          <p:cNvPr id="31" name="Rectangle 30"/>
           <p:cNvSpPr/>
           <p:nvPr/>
         </p:nvSpPr>
         <p:spPr>
           <a:xfrm>
-            <a:off x="9978991" y="1371600"/>
-            <a:ext cx="451906" cy="329184"/>
+            <a:off x="10655198" y="1371600"/>
+            <a:ext cx="574852" cy="329184"/>
           </a:xfrm>
           <a:prstGeom prst="rect">
             <a:avLst/>
@@ -12099,14 +11945,14 @@
       </p:sp>
       <p:sp>
         <p:nvSpPr>
-          <p:cNvPr id="36" name="TextBox 35"/>
-          <p:cNvSpPr txBox="1"/>
-          <p:nvPr/>
-        </p:nvSpPr>
-        <p:spPr>
-          <a:xfrm>
-            <a:off x="9978991" y="1380744"/>
-            <a:ext cx="461050" cy="329184"/>
+          <p:cNvPr id="32" name="TextBox 31"/>
+          <p:cNvSpPr txBox="1"/>
+          <p:nvPr/>
+        </p:nvSpPr>
+        <p:spPr>
+          <a:xfrm>
+            <a:off x="10655198" y="1380744"/>
+            <a:ext cx="583996" cy="329184"/>
           </a:xfrm>
           <a:prstGeom prst="rect">
             <a:avLst/>
@@ -12127,7 +11973,7 @@
                 </a:solidFill>
                 <a:latin typeface="Calibri"/>
               </a:rPr>
-              <a:t>Jan</a:t>
+              <a:t>Nov</a:t>
             </a:r>
           </a:p>
           <a:p>
@@ -12139,21 +11985,21 @@
                 </a:solidFill>
                 <a:latin typeface="Calibri"/>
               </a:rPr>
-              <a:t>28</a:t>
-            </a:r>
-          </a:p>
-        </p:txBody>
-      </p:sp>
-      <p:sp>
-        <p:nvSpPr>
-          <p:cNvPr id="37" name="Rectangle 36"/>
+              <a:t>27</a:t>
+            </a:r>
+          </a:p>
+        </p:txBody>
+      </p:sp>
+      <p:sp>
+        <p:nvSpPr>
+          <p:cNvPr id="33" name="Rectangle 32"/>
           <p:cNvSpPr/>
           <p:nvPr/>
         </p:nvSpPr>
         <p:spPr>
           <a:xfrm>
-            <a:off x="10440041" y="1371600"/>
-            <a:ext cx="451906" cy="329184"/>
+            <a:off x="11239195" y="1371600"/>
+            <a:ext cx="574852" cy="329184"/>
           </a:xfrm>
           <a:prstGeom prst="rect">
             <a:avLst/>
@@ -12176,14 +12022,14 @@
       </p:sp>
       <p:sp>
         <p:nvSpPr>
-          <p:cNvPr id="38" name="TextBox 37"/>
-          <p:cNvSpPr txBox="1"/>
-          <p:nvPr/>
-        </p:nvSpPr>
-        <p:spPr>
-          <a:xfrm>
-            <a:off x="10440041" y="1380744"/>
-            <a:ext cx="461050" cy="329184"/>
+          <p:cNvPr id="34" name="TextBox 33"/>
+          <p:cNvSpPr txBox="1"/>
+          <p:nvPr/>
+        </p:nvSpPr>
+        <p:spPr>
+          <a:xfrm>
+            <a:off x="11239195" y="1380744"/>
+            <a:ext cx="583996" cy="329184"/>
           </a:xfrm>
           <a:prstGeom prst="rect">
             <a:avLst/>
@@ -12204,7 +12050,7 @@
                 </a:solidFill>
                 <a:latin typeface="Calibri"/>
               </a:rPr>
-              <a:t>Feb</a:t>
+              <a:t>Des</a:t>
             </a:r>
           </a:p>
           <a:p>
@@ -12216,168 +12062,14 @@
                 </a:solidFill>
                 <a:latin typeface="Calibri"/>
               </a:rPr>
-              <a:t>28</a:t>
-            </a:r>
-          </a:p>
-        </p:txBody>
-      </p:sp>
-      <p:sp>
-        <p:nvSpPr>
-          <p:cNvPr id="39" name="Rectangle 38"/>
-          <p:cNvSpPr/>
-          <p:nvPr/>
-        </p:nvSpPr>
-        <p:spPr>
-          <a:xfrm>
-            <a:off x="10901091" y="1371600"/>
-            <a:ext cx="451906" cy="329184"/>
-          </a:xfrm>
-          <a:prstGeom prst="rect">
-            <a:avLst/>
-          </a:prstGeom>
-          <a:solidFill>
-            <a:srgbClr val="F6EBDD"/>
-          </a:solidFill>
-          <a:ln>
-            <a:noFill/>
-          </a:ln>
-          <a:effectLst/>
-        </p:spPr>
-        <p:txBody>
-          <a:bodyPr rtlCol="0" anchor="ctr"/>
-          <a:lstStyle/>
-          <a:p>
-            <a:pPr algn="ctr"/>
-          </a:p>
-        </p:txBody>
-      </p:sp>
-      <p:sp>
-        <p:nvSpPr>
-          <p:cNvPr id="40" name="TextBox 39"/>
-          <p:cNvSpPr txBox="1"/>
-          <p:nvPr/>
-        </p:nvSpPr>
-        <p:spPr>
-          <a:xfrm>
-            <a:off x="10901091" y="1380744"/>
-            <a:ext cx="461050" cy="329184"/>
-          </a:xfrm>
-          <a:prstGeom prst="rect">
-            <a:avLst/>
-          </a:prstGeom>
-          <a:noFill/>
-        </p:spPr>
-        <p:txBody>
-          <a:bodyPr wrap="square" lIns="18288" rIns="18288" tIns="9144" bIns="9144" anchor="t">
-            <a:spAutoFit/>
-          </a:bodyPr>
-          <a:lstStyle/>
-          <a:p>
-            <a:pPr algn="ctr"/>
-            <a:r>
-              <a:rPr sz="650" b="0" i="0">
-                <a:solidFill>
-                  <a:srgbClr val="5F6B65"/>
-                </a:solidFill>
-                <a:latin typeface="Calibri"/>
-              </a:rPr>
-              <a:t>Mar</a:t>
-            </a:r>
-          </a:p>
-          <a:p>
-            <a:pPr algn="ctr"/>
-            <a:r>
-              <a:rPr sz="650" b="0" i="0">
-                <a:solidFill>
-                  <a:srgbClr val="5F6B65"/>
-                </a:solidFill>
-                <a:latin typeface="Calibri"/>
-              </a:rPr>
-              <a:t>28</a:t>
-            </a:r>
-          </a:p>
-        </p:txBody>
-      </p:sp>
-      <p:sp>
-        <p:nvSpPr>
-          <p:cNvPr id="41" name="Rectangle 40"/>
-          <p:cNvSpPr/>
-          <p:nvPr/>
-        </p:nvSpPr>
-        <p:spPr>
-          <a:xfrm>
-            <a:off x="11362141" y="1371600"/>
-            <a:ext cx="451906" cy="329184"/>
-          </a:xfrm>
-          <a:prstGeom prst="rect">
-            <a:avLst/>
-          </a:prstGeom>
-          <a:solidFill>
-            <a:srgbClr val="F6EBDD"/>
-          </a:solidFill>
-          <a:ln>
-            <a:noFill/>
-          </a:ln>
-          <a:effectLst/>
-        </p:spPr>
-        <p:txBody>
-          <a:bodyPr rtlCol="0" anchor="ctr"/>
-          <a:lstStyle/>
-          <a:p>
-            <a:pPr algn="ctr"/>
-          </a:p>
-        </p:txBody>
-      </p:sp>
-      <p:sp>
-        <p:nvSpPr>
-          <p:cNvPr id="42" name="TextBox 41"/>
-          <p:cNvSpPr txBox="1"/>
-          <p:nvPr/>
-        </p:nvSpPr>
-        <p:spPr>
-          <a:xfrm>
-            <a:off x="11362141" y="1380744"/>
-            <a:ext cx="461050" cy="329184"/>
-          </a:xfrm>
-          <a:prstGeom prst="rect">
-            <a:avLst/>
-          </a:prstGeom>
-          <a:noFill/>
-        </p:spPr>
-        <p:txBody>
-          <a:bodyPr wrap="square" lIns="18288" rIns="18288" tIns="9144" bIns="9144" anchor="t">
-            <a:spAutoFit/>
-          </a:bodyPr>
-          <a:lstStyle/>
-          <a:p>
-            <a:pPr algn="ctr"/>
-            <a:r>
-              <a:rPr sz="650" b="0" i="0">
-                <a:solidFill>
-                  <a:srgbClr val="5F6B65"/>
-                </a:solidFill>
-                <a:latin typeface="Calibri"/>
-              </a:rPr>
-              <a:t>Apr</a:t>
-            </a:r>
-          </a:p>
-          <a:p>
-            <a:pPr algn="ctr"/>
-            <a:r>
-              <a:rPr sz="650" b="0" i="0">
-                <a:solidFill>
-                  <a:srgbClr val="5F6B65"/>
-                </a:solidFill>
-                <a:latin typeface="Calibri"/>
-              </a:rPr>
-              <a:t>28</a:t>
+              <a:t>27</a:t>
             </a:r>
           </a:p>
         </p:txBody>
       </p:sp>
       <p:cxnSp>
         <p:nvCxnSpPr>
-          <p:cNvPr id="43" name="Connector 42"/>
+          <p:cNvPr id="35" name="Connector 34"/>
           <p:cNvCxnSpPr/>
           <p:nvPr/>
         </p:nvCxnSpPr>
@@ -12412,7 +12104,7 @@
       </p:cxnSp>
       <p:sp>
         <p:nvSpPr>
-          <p:cNvPr id="44" name="TextBox 43"/>
+          <p:cNvPr id="36" name="TextBox 35"/>
           <p:cNvSpPr txBox="1"/>
           <p:nvPr/>
         </p:nvSpPr>
@@ -12447,7 +12139,7 @@
       </p:sp>
       <p:sp>
         <p:nvSpPr>
-          <p:cNvPr id="45" name="TextBox 44"/>
+          <p:cNvPr id="37" name="TextBox 36"/>
           <p:cNvSpPr txBox="1"/>
           <p:nvPr/>
         </p:nvSpPr>
@@ -12482,14 +12174,14 @@
       </p:sp>
       <p:sp>
         <p:nvSpPr>
-          <p:cNvPr id="46" name="Rectangle 45"/>
+          <p:cNvPr id="38" name="Rectangle 37"/>
           <p:cNvSpPr/>
           <p:nvPr/>
         </p:nvSpPr>
         <p:spPr>
           <a:xfrm>
             <a:off x="3072384" y="1777502"/>
-            <a:ext cx="442762" cy="65562"/>
+            <a:ext cx="565708" cy="65562"/>
           </a:xfrm>
           <a:prstGeom prst="rect">
             <a:avLst/>
@@ -12512,7 +12204,7 @@
       </p:sp>
       <p:sp>
         <p:nvSpPr>
-          <p:cNvPr id="47" name="TextBox 46"/>
+          <p:cNvPr id="39" name="TextBox 38"/>
           <p:cNvSpPr txBox="1"/>
           <p:nvPr/>
         </p:nvSpPr>
@@ -12547,7 +12239,7 @@
       </p:sp>
       <p:sp>
         <p:nvSpPr>
-          <p:cNvPr id="48" name="TextBox 47"/>
+          <p:cNvPr id="40" name="TextBox 39"/>
           <p:cNvSpPr txBox="1"/>
           <p:nvPr/>
         </p:nvSpPr>
@@ -12582,14 +12274,14 @@
       </p:sp>
       <p:sp>
         <p:nvSpPr>
-          <p:cNvPr id="49" name="Rectangle 48"/>
+          <p:cNvPr id="41" name="Rectangle 40"/>
           <p:cNvSpPr/>
           <p:nvPr/>
         </p:nvSpPr>
         <p:spPr>
           <a:xfrm>
             <a:off x="3072384" y="1886772"/>
-            <a:ext cx="903812" cy="65562"/>
+            <a:ext cx="565708" cy="65562"/>
           </a:xfrm>
           <a:prstGeom prst="rect">
             <a:avLst/>
@@ -12612,7 +12304,7 @@
       </p:sp>
       <p:sp>
         <p:nvSpPr>
-          <p:cNvPr id="50" name="TextBox 49"/>
+          <p:cNvPr id="42" name="TextBox 41"/>
           <p:cNvSpPr txBox="1"/>
           <p:nvPr/>
         </p:nvSpPr>
@@ -12647,7 +12339,7 @@
       </p:sp>
       <p:sp>
         <p:nvSpPr>
-          <p:cNvPr id="51" name="TextBox 50"/>
+          <p:cNvPr id="43" name="TextBox 42"/>
           <p:cNvSpPr txBox="1"/>
           <p:nvPr/>
         </p:nvSpPr>
@@ -12682,14 +12374,14 @@
       </p:sp>
       <p:sp>
         <p:nvSpPr>
-          <p:cNvPr id="52" name="Rectangle 51"/>
+          <p:cNvPr id="44" name="Rectangle 43"/>
           <p:cNvSpPr/>
           <p:nvPr/>
         </p:nvSpPr>
         <p:spPr>
           <a:xfrm>
-            <a:off x="3533434" y="1996043"/>
-            <a:ext cx="903812" cy="65562"/>
+            <a:off x="3072384" y="1996043"/>
+            <a:ext cx="1149705" cy="65562"/>
           </a:xfrm>
           <a:prstGeom prst="rect">
             <a:avLst/>
@@ -12712,7 +12404,7 @@
       </p:sp>
       <p:sp>
         <p:nvSpPr>
-          <p:cNvPr id="53" name="TextBox 52"/>
+          <p:cNvPr id="45" name="TextBox 44"/>
           <p:cNvSpPr txBox="1"/>
           <p:nvPr/>
         </p:nvSpPr>
@@ -12747,7 +12439,7 @@
       </p:sp>
       <p:sp>
         <p:nvSpPr>
-          <p:cNvPr id="54" name="TextBox 53"/>
+          <p:cNvPr id="46" name="TextBox 45"/>
           <p:cNvSpPr txBox="1"/>
           <p:nvPr/>
         </p:nvSpPr>
@@ -12782,14 +12474,14 @@
       </p:sp>
       <p:sp>
         <p:nvSpPr>
-          <p:cNvPr id="55" name="Rectangle 54"/>
+          <p:cNvPr id="47" name="Rectangle 46"/>
           <p:cNvSpPr/>
           <p:nvPr/>
         </p:nvSpPr>
         <p:spPr>
           <a:xfrm>
             <a:off x="3072384" y="2105314"/>
-            <a:ext cx="1364862" cy="65562"/>
+            <a:ext cx="1149705" cy="65562"/>
           </a:xfrm>
           <a:prstGeom prst="rect">
             <a:avLst/>
@@ -12812,7 +12504,7 @@
       </p:sp>
       <p:cxnSp>
         <p:nvCxnSpPr>
-          <p:cNvPr id="56" name="Connector 55"/>
+          <p:cNvPr id="48" name="Connector 47"/>
           <p:cNvCxnSpPr/>
           <p:nvPr/>
         </p:nvCxnSpPr>
@@ -12847,7 +12539,7 @@
       </p:cxnSp>
       <p:sp>
         <p:nvSpPr>
-          <p:cNvPr id="57" name="TextBox 56"/>
+          <p:cNvPr id="49" name="TextBox 48"/>
           <p:cNvSpPr txBox="1"/>
           <p:nvPr/>
         </p:nvSpPr>
@@ -12882,7 +12574,7 @@
       </p:sp>
       <p:sp>
         <p:nvSpPr>
-          <p:cNvPr id="58" name="TextBox 57"/>
+          <p:cNvPr id="50" name="TextBox 49"/>
           <p:cNvSpPr txBox="1"/>
           <p:nvPr/>
         </p:nvSpPr>
@@ -12917,14 +12609,14 @@
       </p:sp>
       <p:sp>
         <p:nvSpPr>
-          <p:cNvPr id="59" name="Rectangle 58"/>
+          <p:cNvPr id="51" name="Rectangle 50"/>
           <p:cNvSpPr/>
           <p:nvPr/>
         </p:nvSpPr>
         <p:spPr>
           <a:xfrm>
-            <a:off x="3533434" y="2214585"/>
-            <a:ext cx="903812" cy="65562"/>
+            <a:off x="3656380" y="2214585"/>
+            <a:ext cx="565708" cy="65562"/>
           </a:xfrm>
           <a:prstGeom prst="rect">
             <a:avLst/>
@@ -12947,7 +12639,7 @@
       </p:sp>
       <p:sp>
         <p:nvSpPr>
-          <p:cNvPr id="60" name="TextBox 59"/>
+          <p:cNvPr id="52" name="TextBox 51"/>
           <p:cNvSpPr txBox="1"/>
           <p:nvPr/>
         </p:nvSpPr>
@@ -12982,7 +12674,7 @@
       </p:sp>
       <p:sp>
         <p:nvSpPr>
-          <p:cNvPr id="61" name="TextBox 60"/>
+          <p:cNvPr id="53" name="TextBox 52"/>
           <p:cNvSpPr txBox="1"/>
           <p:nvPr/>
         </p:nvSpPr>
@@ -13017,14 +12709,14 @@
       </p:sp>
       <p:sp>
         <p:nvSpPr>
-          <p:cNvPr id="62" name="Rectangle 61"/>
+          <p:cNvPr id="54" name="Rectangle 53"/>
           <p:cNvSpPr/>
           <p:nvPr/>
         </p:nvSpPr>
         <p:spPr>
           <a:xfrm>
-            <a:off x="3994484" y="2323856"/>
-            <a:ext cx="903812" cy="65562"/>
+            <a:off x="3656380" y="2323856"/>
+            <a:ext cx="1149705" cy="65562"/>
           </a:xfrm>
           <a:prstGeom prst="rect">
             <a:avLst/>
@@ -13047,7 +12739,7 @@
       </p:sp>
       <p:sp>
         <p:nvSpPr>
-          <p:cNvPr id="63" name="TextBox 62"/>
+          <p:cNvPr id="55" name="TextBox 54"/>
           <p:cNvSpPr txBox="1"/>
           <p:nvPr/>
         </p:nvSpPr>
@@ -13082,7 +12774,7 @@
       </p:sp>
       <p:sp>
         <p:nvSpPr>
-          <p:cNvPr id="64" name="TextBox 63"/>
+          <p:cNvPr id="56" name="TextBox 55"/>
           <p:cNvSpPr txBox="1"/>
           <p:nvPr/>
         </p:nvSpPr>
@@ -13117,14 +12809,14 @@
       </p:sp>
       <p:sp>
         <p:nvSpPr>
-          <p:cNvPr id="65" name="Rectangle 64"/>
+          <p:cNvPr id="57" name="Rectangle 56"/>
           <p:cNvSpPr/>
           <p:nvPr/>
         </p:nvSpPr>
         <p:spPr>
           <a:xfrm>
-            <a:off x="3994484" y="2433126"/>
-            <a:ext cx="903812" cy="65562"/>
+            <a:off x="3656380" y="2433126"/>
+            <a:ext cx="1149705" cy="65562"/>
           </a:xfrm>
           <a:prstGeom prst="rect">
             <a:avLst/>
@@ -13147,7 +12839,7 @@
       </p:sp>
       <p:sp>
         <p:nvSpPr>
-          <p:cNvPr id="66" name="TextBox 65"/>
+          <p:cNvPr id="58" name="TextBox 57"/>
           <p:cNvSpPr txBox="1"/>
           <p:nvPr/>
         </p:nvSpPr>
@@ -13182,7 +12874,7 @@
       </p:sp>
       <p:sp>
         <p:nvSpPr>
-          <p:cNvPr id="67" name="TextBox 66"/>
+          <p:cNvPr id="59" name="TextBox 58"/>
           <p:cNvSpPr txBox="1"/>
           <p:nvPr/>
         </p:nvSpPr>
@@ -13217,14 +12909,14 @@
       </p:sp>
       <p:sp>
         <p:nvSpPr>
-          <p:cNvPr id="68" name="Rectangle 67"/>
+          <p:cNvPr id="60" name="Rectangle 59"/>
           <p:cNvSpPr/>
           <p:nvPr/>
         </p:nvSpPr>
         <p:spPr>
           <a:xfrm>
-            <a:off x="3994484" y="2542397"/>
-            <a:ext cx="903812" cy="65562"/>
+            <a:off x="3656380" y="2542397"/>
+            <a:ext cx="1149705" cy="65562"/>
           </a:xfrm>
           <a:prstGeom prst="rect">
             <a:avLst/>
@@ -13247,7 +12939,7 @@
       </p:sp>
       <p:sp>
         <p:nvSpPr>
-          <p:cNvPr id="69" name="TextBox 68"/>
+          <p:cNvPr id="61" name="TextBox 60"/>
           <p:cNvSpPr txBox="1"/>
           <p:nvPr/>
         </p:nvSpPr>
@@ -13282,7 +12974,7 @@
       </p:sp>
       <p:sp>
         <p:nvSpPr>
-          <p:cNvPr id="70" name="TextBox 69"/>
+          <p:cNvPr id="62" name="TextBox 61"/>
           <p:cNvSpPr txBox="1"/>
           <p:nvPr/>
         </p:nvSpPr>
@@ -13317,14 +13009,14 @@
       </p:sp>
       <p:sp>
         <p:nvSpPr>
-          <p:cNvPr id="71" name="Rectangle 70"/>
+          <p:cNvPr id="63" name="Rectangle 62"/>
           <p:cNvSpPr/>
           <p:nvPr/>
         </p:nvSpPr>
         <p:spPr>
           <a:xfrm>
-            <a:off x="4455534" y="2651668"/>
-            <a:ext cx="442762" cy="65562"/>
+            <a:off x="4240377" y="2651668"/>
+            <a:ext cx="565708" cy="65562"/>
           </a:xfrm>
           <a:prstGeom prst="rect">
             <a:avLst/>
@@ -13347,7 +13039,7 @@
       </p:sp>
       <p:cxnSp>
         <p:nvCxnSpPr>
-          <p:cNvPr id="72" name="Connector 71"/>
+          <p:cNvPr id="64" name="Connector 63"/>
           <p:cNvCxnSpPr/>
           <p:nvPr/>
         </p:nvCxnSpPr>
@@ -13382,7 +13074,7 @@
       </p:cxnSp>
       <p:sp>
         <p:nvSpPr>
-          <p:cNvPr id="73" name="TextBox 72"/>
+          <p:cNvPr id="65" name="TextBox 64"/>
           <p:cNvSpPr txBox="1"/>
           <p:nvPr/>
         </p:nvSpPr>
@@ -13417,7 +13109,7 @@
       </p:sp>
       <p:sp>
         <p:nvSpPr>
-          <p:cNvPr id="74" name="TextBox 73"/>
+          <p:cNvPr id="66" name="TextBox 65"/>
           <p:cNvSpPr txBox="1"/>
           <p:nvPr/>
         </p:nvSpPr>
@@ -13452,14 +13144,14 @@
       </p:sp>
       <p:sp>
         <p:nvSpPr>
-          <p:cNvPr id="75" name="Rectangle 74"/>
+          <p:cNvPr id="67" name="Rectangle 66"/>
           <p:cNvSpPr/>
           <p:nvPr/>
         </p:nvSpPr>
         <p:spPr>
           <a:xfrm>
-            <a:off x="4455534" y="2760939"/>
-            <a:ext cx="903812" cy="65562"/>
+            <a:off x="4240377" y="2760939"/>
+            <a:ext cx="1149705" cy="65562"/>
           </a:xfrm>
           <a:prstGeom prst="rect">
             <a:avLst/>
@@ -13482,7 +13174,7 @@
       </p:sp>
       <p:sp>
         <p:nvSpPr>
-          <p:cNvPr id="76" name="TextBox 75"/>
+          <p:cNvPr id="68" name="TextBox 67"/>
           <p:cNvSpPr txBox="1"/>
           <p:nvPr/>
         </p:nvSpPr>
@@ -13517,7 +13209,7 @@
       </p:sp>
       <p:sp>
         <p:nvSpPr>
-          <p:cNvPr id="77" name="TextBox 76"/>
+          <p:cNvPr id="69" name="TextBox 68"/>
           <p:cNvSpPr txBox="1"/>
           <p:nvPr/>
         </p:nvSpPr>
@@ -13552,14 +13244,14 @@
       </p:sp>
       <p:sp>
         <p:nvSpPr>
-          <p:cNvPr id="78" name="Rectangle 77"/>
+          <p:cNvPr id="70" name="Rectangle 69"/>
           <p:cNvSpPr/>
           <p:nvPr/>
         </p:nvSpPr>
         <p:spPr>
           <a:xfrm>
-            <a:off x="4916584" y="2870210"/>
-            <a:ext cx="1825912" cy="65562"/>
+            <a:off x="4824374" y="2870210"/>
+            <a:ext cx="1733702" cy="65562"/>
           </a:xfrm>
           <a:prstGeom prst="rect">
             <a:avLst/>
@@ -13582,7 +13274,7 @@
       </p:sp>
       <p:sp>
         <p:nvSpPr>
-          <p:cNvPr id="79" name="TextBox 78"/>
+          <p:cNvPr id="71" name="TextBox 70"/>
           <p:cNvSpPr txBox="1"/>
           <p:nvPr/>
         </p:nvSpPr>
@@ -13617,7 +13309,7 @@
       </p:sp>
       <p:sp>
         <p:nvSpPr>
-          <p:cNvPr id="80" name="TextBox 79"/>
+          <p:cNvPr id="72" name="TextBox 71"/>
           <p:cNvSpPr txBox="1"/>
           <p:nvPr/>
         </p:nvSpPr>
@@ -13652,14 +13344,14 @@
       </p:sp>
       <p:sp>
         <p:nvSpPr>
-          <p:cNvPr id="81" name="Rectangle 80"/>
+          <p:cNvPr id="73" name="Rectangle 72"/>
           <p:cNvSpPr/>
           <p:nvPr/>
         </p:nvSpPr>
         <p:spPr>
           <a:xfrm>
-            <a:off x="4916584" y="2979480"/>
-            <a:ext cx="1825912" cy="65562"/>
+            <a:off x="4824374" y="2979480"/>
+            <a:ext cx="1149705" cy="65562"/>
           </a:xfrm>
           <a:prstGeom prst="rect">
             <a:avLst/>
@@ -13682,7 +13374,7 @@
       </p:sp>
       <p:sp>
         <p:nvSpPr>
-          <p:cNvPr id="82" name="TextBox 81"/>
+          <p:cNvPr id="74" name="TextBox 73"/>
           <p:cNvSpPr txBox="1"/>
           <p:nvPr/>
         </p:nvSpPr>
@@ -13717,7 +13409,7 @@
       </p:sp>
       <p:sp>
         <p:nvSpPr>
-          <p:cNvPr id="83" name="TextBox 82"/>
+          <p:cNvPr id="75" name="TextBox 74"/>
           <p:cNvSpPr txBox="1"/>
           <p:nvPr/>
         </p:nvSpPr>
@@ -13752,14 +13444,14 @@
       </p:sp>
       <p:sp>
         <p:nvSpPr>
-          <p:cNvPr id="84" name="Rectangle 83"/>
+          <p:cNvPr id="76" name="Rectangle 75"/>
           <p:cNvSpPr/>
           <p:nvPr/>
         </p:nvSpPr>
         <p:spPr>
           <a:xfrm>
-            <a:off x="5838684" y="3088751"/>
-            <a:ext cx="903812" cy="65562"/>
+            <a:off x="5408371" y="3088751"/>
+            <a:ext cx="565708" cy="65562"/>
           </a:xfrm>
           <a:prstGeom prst="rect">
             <a:avLst/>
@@ -13782,7 +13474,7 @@
       </p:sp>
       <p:sp>
         <p:nvSpPr>
-          <p:cNvPr id="85" name="TextBox 84"/>
+          <p:cNvPr id="77" name="TextBox 76"/>
           <p:cNvSpPr txBox="1"/>
           <p:nvPr/>
         </p:nvSpPr>
@@ -13817,7 +13509,7 @@
       </p:sp>
       <p:sp>
         <p:nvSpPr>
-          <p:cNvPr id="86" name="TextBox 85"/>
+          <p:cNvPr id="78" name="TextBox 77"/>
           <p:cNvSpPr txBox="1"/>
           <p:nvPr/>
         </p:nvSpPr>
@@ -13852,14 +13544,14 @@
       </p:sp>
       <p:sp>
         <p:nvSpPr>
-          <p:cNvPr id="87" name="Rectangle 86"/>
+          <p:cNvPr id="79" name="Rectangle 78"/>
           <p:cNvSpPr/>
           <p:nvPr/>
         </p:nvSpPr>
         <p:spPr>
           <a:xfrm>
-            <a:off x="6299734" y="3198022"/>
-            <a:ext cx="903812" cy="65562"/>
+            <a:off x="5992367" y="3198022"/>
+            <a:ext cx="565708" cy="65562"/>
           </a:xfrm>
           <a:prstGeom prst="rect">
             <a:avLst/>
@@ -13882,7 +13574,7 @@
       </p:sp>
       <p:sp>
         <p:nvSpPr>
-          <p:cNvPr id="88" name="TextBox 87"/>
+          <p:cNvPr id="80" name="TextBox 79"/>
           <p:cNvSpPr txBox="1"/>
           <p:nvPr/>
         </p:nvSpPr>
@@ -13917,7 +13609,7 @@
       </p:sp>
       <p:sp>
         <p:nvSpPr>
-          <p:cNvPr id="89" name="TextBox 88"/>
+          <p:cNvPr id="81" name="TextBox 80"/>
           <p:cNvSpPr txBox="1"/>
           <p:nvPr/>
         </p:nvSpPr>
@@ -13952,14 +13644,14 @@
       </p:sp>
       <p:sp>
         <p:nvSpPr>
-          <p:cNvPr id="90" name="Rectangle 89"/>
+          <p:cNvPr id="82" name="Rectangle 81"/>
           <p:cNvSpPr/>
           <p:nvPr/>
         </p:nvSpPr>
         <p:spPr>
           <a:xfrm>
-            <a:off x="6760784" y="3307293"/>
-            <a:ext cx="903812" cy="65562"/>
+            <a:off x="5992367" y="3307293"/>
+            <a:ext cx="1149705" cy="65562"/>
           </a:xfrm>
           <a:prstGeom prst="rect">
             <a:avLst/>
@@ -13982,7 +13674,7 @@
       </p:sp>
       <p:sp>
         <p:nvSpPr>
-          <p:cNvPr id="91" name="TextBox 90"/>
+          <p:cNvPr id="83" name="TextBox 82"/>
           <p:cNvSpPr txBox="1"/>
           <p:nvPr/>
         </p:nvSpPr>
@@ -14017,7 +13709,7 @@
       </p:sp>
       <p:sp>
         <p:nvSpPr>
-          <p:cNvPr id="92" name="TextBox 91"/>
+          <p:cNvPr id="84" name="TextBox 83"/>
           <p:cNvSpPr txBox="1"/>
           <p:nvPr/>
         </p:nvSpPr>
@@ -14052,14 +13744,14 @@
       </p:sp>
       <p:sp>
         <p:nvSpPr>
-          <p:cNvPr id="93" name="Rectangle 92"/>
+          <p:cNvPr id="85" name="Rectangle 84"/>
           <p:cNvSpPr/>
           <p:nvPr/>
         </p:nvSpPr>
         <p:spPr>
           <a:xfrm>
-            <a:off x="4916584" y="3416564"/>
-            <a:ext cx="2286962" cy="65562"/>
+            <a:off x="4824374" y="3416564"/>
+            <a:ext cx="1733702" cy="65562"/>
           </a:xfrm>
           <a:prstGeom prst="rect">
             <a:avLst/>
@@ -14082,7 +13774,7 @@
       </p:sp>
       <p:cxnSp>
         <p:nvCxnSpPr>
-          <p:cNvPr id="94" name="Connector 93"/>
+          <p:cNvPr id="86" name="Connector 85"/>
           <p:cNvCxnSpPr/>
           <p:nvPr/>
         </p:nvCxnSpPr>
@@ -14117,7 +13809,7 @@
       </p:cxnSp>
       <p:sp>
         <p:nvSpPr>
-          <p:cNvPr id="95" name="TextBox 94"/>
+          <p:cNvPr id="87" name="TextBox 86"/>
           <p:cNvSpPr txBox="1"/>
           <p:nvPr/>
         </p:nvSpPr>
@@ -14152,7 +13844,7 @@
       </p:sp>
       <p:sp>
         <p:nvSpPr>
-          <p:cNvPr id="96" name="TextBox 95"/>
+          <p:cNvPr id="88" name="TextBox 87"/>
           <p:cNvSpPr txBox="1"/>
           <p:nvPr/>
         </p:nvSpPr>
@@ -14187,14 +13879,14 @@
       </p:sp>
       <p:sp>
         <p:nvSpPr>
-          <p:cNvPr id="97" name="Rectangle 96"/>
+          <p:cNvPr id="89" name="Rectangle 88"/>
           <p:cNvSpPr/>
           <p:nvPr/>
         </p:nvSpPr>
         <p:spPr>
           <a:xfrm>
-            <a:off x="5377634" y="3525834"/>
-            <a:ext cx="2286962" cy="65562"/>
+            <a:off x="4824374" y="3525834"/>
+            <a:ext cx="3485692" cy="65562"/>
           </a:xfrm>
           <a:prstGeom prst="rect">
             <a:avLst/>
@@ -14217,7 +13909,7 @@
       </p:sp>
       <p:sp>
         <p:nvSpPr>
-          <p:cNvPr id="98" name="TextBox 97"/>
+          <p:cNvPr id="90" name="TextBox 89"/>
           <p:cNvSpPr txBox="1"/>
           <p:nvPr/>
         </p:nvSpPr>
@@ -14252,7 +13944,7 @@
       </p:sp>
       <p:sp>
         <p:nvSpPr>
-          <p:cNvPr id="99" name="TextBox 98"/>
+          <p:cNvPr id="91" name="TextBox 90"/>
           <p:cNvSpPr txBox="1"/>
           <p:nvPr/>
         </p:nvSpPr>
@@ -14287,14 +13979,14 @@
       </p:sp>
       <p:sp>
         <p:nvSpPr>
-          <p:cNvPr id="100" name="Rectangle 99"/>
+          <p:cNvPr id="92" name="Rectangle 91"/>
           <p:cNvSpPr/>
           <p:nvPr/>
         </p:nvSpPr>
         <p:spPr>
           <a:xfrm>
-            <a:off x="5377634" y="3635105"/>
-            <a:ext cx="1825912" cy="65562"/>
+            <a:off x="4824374" y="3635105"/>
+            <a:ext cx="2317699" cy="65562"/>
           </a:xfrm>
           <a:prstGeom prst="rect">
             <a:avLst/>
@@ -14317,7 +14009,7 @@
       </p:sp>
       <p:sp>
         <p:nvSpPr>
-          <p:cNvPr id="101" name="TextBox 100"/>
+          <p:cNvPr id="93" name="TextBox 92"/>
           <p:cNvSpPr txBox="1"/>
           <p:nvPr/>
         </p:nvSpPr>
@@ -14352,7 +14044,7 @@
       </p:sp>
       <p:sp>
         <p:nvSpPr>
-          <p:cNvPr id="102" name="TextBox 101"/>
+          <p:cNvPr id="94" name="TextBox 93"/>
           <p:cNvSpPr txBox="1"/>
           <p:nvPr/>
         </p:nvSpPr>
@@ -14387,14 +14079,14 @@
       </p:sp>
       <p:sp>
         <p:nvSpPr>
-          <p:cNvPr id="103" name="Rectangle 102"/>
+          <p:cNvPr id="95" name="Rectangle 94"/>
           <p:cNvSpPr/>
           <p:nvPr/>
         </p:nvSpPr>
         <p:spPr>
           <a:xfrm>
-            <a:off x="5838684" y="3744376"/>
-            <a:ext cx="1825912" cy="65562"/>
+            <a:off x="5408371" y="3744376"/>
+            <a:ext cx="2317699" cy="65562"/>
           </a:xfrm>
           <a:prstGeom prst="rect">
             <a:avLst/>
@@ -14417,7 +14109,7 @@
       </p:sp>
       <p:sp>
         <p:nvSpPr>
-          <p:cNvPr id="104" name="TextBox 103"/>
+          <p:cNvPr id="96" name="TextBox 95"/>
           <p:cNvSpPr txBox="1"/>
           <p:nvPr/>
         </p:nvSpPr>
@@ -14452,7 +14144,7 @@
       </p:sp>
       <p:sp>
         <p:nvSpPr>
-          <p:cNvPr id="105" name="TextBox 104"/>
+          <p:cNvPr id="97" name="TextBox 96"/>
           <p:cNvSpPr txBox="1"/>
           <p:nvPr/>
         </p:nvSpPr>
@@ -14487,14 +14179,14 @@
       </p:sp>
       <p:sp>
         <p:nvSpPr>
-          <p:cNvPr id="106" name="Rectangle 105"/>
+          <p:cNvPr id="98" name="Rectangle 97"/>
           <p:cNvSpPr/>
           <p:nvPr/>
         </p:nvSpPr>
         <p:spPr>
           <a:xfrm>
-            <a:off x="6299734" y="3853647"/>
-            <a:ext cx="1825912" cy="65562"/>
+            <a:off x="5408371" y="3853647"/>
+            <a:ext cx="1733702" cy="65562"/>
           </a:xfrm>
           <a:prstGeom prst="rect">
             <a:avLst/>
@@ -14517,7 +14209,7 @@
       </p:sp>
       <p:sp>
         <p:nvSpPr>
-          <p:cNvPr id="107" name="TextBox 106"/>
+          <p:cNvPr id="99" name="TextBox 98"/>
           <p:cNvSpPr txBox="1"/>
           <p:nvPr/>
         </p:nvSpPr>
@@ -14552,7 +14244,7 @@
       </p:sp>
       <p:sp>
         <p:nvSpPr>
-          <p:cNvPr id="108" name="TextBox 107"/>
+          <p:cNvPr id="100" name="TextBox 99"/>
           <p:cNvSpPr txBox="1"/>
           <p:nvPr/>
         </p:nvSpPr>
@@ -14587,14 +14279,14 @@
       </p:sp>
       <p:sp>
         <p:nvSpPr>
-          <p:cNvPr id="109" name="Rectangle 108"/>
+          <p:cNvPr id="101" name="Rectangle 100"/>
           <p:cNvSpPr/>
           <p:nvPr/>
         </p:nvSpPr>
         <p:spPr>
           <a:xfrm>
-            <a:off x="7221834" y="3962918"/>
-            <a:ext cx="1364862" cy="65562"/>
+            <a:off x="6576364" y="3962918"/>
+            <a:ext cx="2317699" cy="65562"/>
           </a:xfrm>
           <a:prstGeom prst="rect">
             <a:avLst/>
@@ -14617,7 +14309,7 @@
       </p:sp>
       <p:sp>
         <p:nvSpPr>
-          <p:cNvPr id="110" name="TextBox 109"/>
+          <p:cNvPr id="102" name="TextBox 101"/>
           <p:cNvSpPr txBox="1"/>
           <p:nvPr/>
         </p:nvSpPr>
@@ -14652,7 +14344,7 @@
       </p:sp>
       <p:sp>
         <p:nvSpPr>
-          <p:cNvPr id="111" name="TextBox 110"/>
+          <p:cNvPr id="103" name="TextBox 102"/>
           <p:cNvSpPr txBox="1"/>
           <p:nvPr/>
         </p:nvSpPr>
@@ -14687,14 +14379,14 @@
       </p:sp>
       <p:sp>
         <p:nvSpPr>
-          <p:cNvPr id="112" name="Rectangle 111"/>
+          <p:cNvPr id="104" name="Rectangle 103"/>
           <p:cNvSpPr/>
           <p:nvPr/>
         </p:nvSpPr>
         <p:spPr>
           <a:xfrm>
-            <a:off x="6299734" y="4072188"/>
-            <a:ext cx="2286962" cy="65562"/>
+            <a:off x="5992367" y="4072188"/>
+            <a:ext cx="2901696" cy="65562"/>
           </a:xfrm>
           <a:prstGeom prst="rect">
             <a:avLst/>
@@ -14717,7 +14409,7 @@
       </p:sp>
       <p:cxnSp>
         <p:nvCxnSpPr>
-          <p:cNvPr id="113" name="Connector 112"/>
+          <p:cNvPr id="105" name="Connector 104"/>
           <p:cNvCxnSpPr/>
           <p:nvPr/>
         </p:nvCxnSpPr>
@@ -14752,7 +14444,7 @@
       </p:cxnSp>
       <p:sp>
         <p:nvSpPr>
-          <p:cNvPr id="114" name="TextBox 113"/>
+          <p:cNvPr id="106" name="TextBox 105"/>
           <p:cNvSpPr txBox="1"/>
           <p:nvPr/>
         </p:nvSpPr>
@@ -14787,7 +14479,7 @@
       </p:sp>
       <p:sp>
         <p:nvSpPr>
-          <p:cNvPr id="115" name="TextBox 114"/>
+          <p:cNvPr id="107" name="TextBox 106"/>
           <p:cNvSpPr txBox="1"/>
           <p:nvPr/>
         </p:nvSpPr>
@@ -14822,14 +14514,14 @@
       </p:sp>
       <p:sp>
         <p:nvSpPr>
-          <p:cNvPr id="116" name="Rectangle 115"/>
+          <p:cNvPr id="108" name="Rectangle 107"/>
           <p:cNvSpPr/>
           <p:nvPr/>
         </p:nvSpPr>
         <p:spPr>
           <a:xfrm>
-            <a:off x="4916584" y="4181459"/>
-            <a:ext cx="903812" cy="65562"/>
+            <a:off x="4240377" y="4181459"/>
+            <a:ext cx="565708" cy="65562"/>
           </a:xfrm>
           <a:prstGeom prst="rect">
             <a:avLst/>
@@ -14852,7 +14544,7 @@
       </p:sp>
       <p:sp>
         <p:nvSpPr>
-          <p:cNvPr id="117" name="TextBox 116"/>
+          <p:cNvPr id="109" name="TextBox 108"/>
           <p:cNvSpPr txBox="1"/>
           <p:nvPr/>
         </p:nvSpPr>
@@ -14887,7 +14579,7 @@
       </p:sp>
       <p:sp>
         <p:nvSpPr>
-          <p:cNvPr id="118" name="TextBox 117"/>
+          <p:cNvPr id="110" name="TextBox 109"/>
           <p:cNvSpPr txBox="1"/>
           <p:nvPr/>
         </p:nvSpPr>
@@ -14922,14 +14614,14 @@
       </p:sp>
       <p:sp>
         <p:nvSpPr>
-          <p:cNvPr id="119" name="Rectangle 118"/>
+          <p:cNvPr id="111" name="Rectangle 110"/>
           <p:cNvSpPr/>
           <p:nvPr/>
         </p:nvSpPr>
         <p:spPr>
           <a:xfrm>
-            <a:off x="5377634" y="4290730"/>
-            <a:ext cx="1364862" cy="65562"/>
+            <a:off x="4240377" y="4290730"/>
+            <a:ext cx="1149705" cy="65562"/>
           </a:xfrm>
           <a:prstGeom prst="rect">
             <a:avLst/>
@@ -14952,7 +14644,7 @@
       </p:sp>
       <p:sp>
         <p:nvSpPr>
-          <p:cNvPr id="120" name="TextBox 119"/>
+          <p:cNvPr id="112" name="TextBox 111"/>
           <p:cNvSpPr txBox="1"/>
           <p:nvPr/>
         </p:nvSpPr>
@@ -14987,7 +14679,7 @@
       </p:sp>
       <p:sp>
         <p:nvSpPr>
-          <p:cNvPr id="121" name="TextBox 120"/>
+          <p:cNvPr id="113" name="TextBox 112"/>
           <p:cNvSpPr txBox="1"/>
           <p:nvPr/>
         </p:nvSpPr>
@@ -15022,14 +14714,14 @@
       </p:sp>
       <p:sp>
         <p:nvSpPr>
-          <p:cNvPr id="122" name="Rectangle 121"/>
+          <p:cNvPr id="114" name="Rectangle 113"/>
           <p:cNvSpPr/>
           <p:nvPr/>
         </p:nvSpPr>
         <p:spPr>
           <a:xfrm>
-            <a:off x="5838684" y="4400001"/>
-            <a:ext cx="903812" cy="65562"/>
+            <a:off x="4824374" y="4400001"/>
+            <a:ext cx="1149705" cy="65562"/>
           </a:xfrm>
           <a:prstGeom prst="rect">
             <a:avLst/>
@@ -15052,7 +14744,7 @@
       </p:sp>
       <p:sp>
         <p:nvSpPr>
-          <p:cNvPr id="123" name="TextBox 122"/>
+          <p:cNvPr id="115" name="TextBox 114"/>
           <p:cNvSpPr txBox="1"/>
           <p:nvPr/>
         </p:nvSpPr>
@@ -15087,7 +14779,7 @@
       </p:sp>
       <p:sp>
         <p:nvSpPr>
-          <p:cNvPr id="124" name="TextBox 123"/>
+          <p:cNvPr id="116" name="TextBox 115"/>
           <p:cNvSpPr txBox="1"/>
           <p:nvPr/>
         </p:nvSpPr>
@@ -15122,14 +14814,14 @@
       </p:sp>
       <p:sp>
         <p:nvSpPr>
-          <p:cNvPr id="125" name="Rectangle 124"/>
+          <p:cNvPr id="117" name="Rectangle 116"/>
           <p:cNvSpPr/>
           <p:nvPr/>
         </p:nvSpPr>
         <p:spPr>
           <a:xfrm>
-            <a:off x="6299734" y="4509272"/>
-            <a:ext cx="903812" cy="65562"/>
+            <a:off x="5408371" y="4509272"/>
+            <a:ext cx="565708" cy="65562"/>
           </a:xfrm>
           <a:prstGeom prst="rect">
             <a:avLst/>
@@ -15152,7 +14844,7 @@
       </p:sp>
       <p:sp>
         <p:nvSpPr>
-          <p:cNvPr id="126" name="TextBox 125"/>
+          <p:cNvPr id="118" name="TextBox 117"/>
           <p:cNvSpPr txBox="1"/>
           <p:nvPr/>
         </p:nvSpPr>
@@ -15187,7 +14879,7 @@
       </p:sp>
       <p:sp>
         <p:nvSpPr>
-          <p:cNvPr id="127" name="TextBox 126"/>
+          <p:cNvPr id="119" name="TextBox 118"/>
           <p:cNvSpPr txBox="1"/>
           <p:nvPr/>
         </p:nvSpPr>
@@ -15222,14 +14914,14 @@
       </p:sp>
       <p:sp>
         <p:nvSpPr>
-          <p:cNvPr id="128" name="Rectangle 127"/>
+          <p:cNvPr id="120" name="Rectangle 119"/>
           <p:cNvSpPr/>
           <p:nvPr/>
         </p:nvSpPr>
         <p:spPr>
           <a:xfrm>
-            <a:off x="6760784" y="4618542"/>
-            <a:ext cx="903812" cy="65562"/>
+            <a:off x="5408371" y="4618542"/>
+            <a:ext cx="1149705" cy="65562"/>
           </a:xfrm>
           <a:prstGeom prst="rect">
             <a:avLst/>
@@ -15252,7 +14944,7 @@
       </p:sp>
       <p:sp>
         <p:nvSpPr>
-          <p:cNvPr id="129" name="TextBox 128"/>
+          <p:cNvPr id="121" name="TextBox 120"/>
           <p:cNvSpPr txBox="1"/>
           <p:nvPr/>
         </p:nvSpPr>
@@ -15287,7 +14979,7 @@
       </p:sp>
       <p:sp>
         <p:nvSpPr>
-          <p:cNvPr id="130" name="TextBox 129"/>
+          <p:cNvPr id="122" name="TextBox 121"/>
           <p:cNvSpPr txBox="1"/>
           <p:nvPr/>
         </p:nvSpPr>
@@ -15322,14 +15014,14 @@
       </p:sp>
       <p:sp>
         <p:nvSpPr>
-          <p:cNvPr id="131" name="Rectangle 130"/>
+          <p:cNvPr id="123" name="Rectangle 122"/>
           <p:cNvSpPr/>
           <p:nvPr/>
         </p:nvSpPr>
         <p:spPr>
           <a:xfrm>
-            <a:off x="7221834" y="4727813"/>
-            <a:ext cx="903812" cy="65562"/>
+            <a:off x="5992367" y="4727813"/>
+            <a:ext cx="1149705" cy="65562"/>
           </a:xfrm>
           <a:prstGeom prst="rect">
             <a:avLst/>
@@ -15352,7 +15044,7 @@
       </p:sp>
       <p:cxnSp>
         <p:nvCxnSpPr>
-          <p:cNvPr id="132" name="Connector 131"/>
+          <p:cNvPr id="124" name="Connector 123"/>
           <p:cNvCxnSpPr/>
           <p:nvPr/>
         </p:nvCxnSpPr>
@@ -15387,7 +15079,7 @@
       </p:cxnSp>
       <p:sp>
         <p:nvSpPr>
-          <p:cNvPr id="133" name="TextBox 132"/>
+          <p:cNvPr id="125" name="TextBox 124"/>
           <p:cNvSpPr txBox="1"/>
           <p:nvPr/>
         </p:nvSpPr>
@@ -15422,7 +15114,7 @@
       </p:sp>
       <p:sp>
         <p:nvSpPr>
-          <p:cNvPr id="134" name="TextBox 133"/>
+          <p:cNvPr id="126" name="TextBox 125"/>
           <p:cNvSpPr txBox="1"/>
           <p:nvPr/>
         </p:nvSpPr>
@@ -15457,14 +15149,14 @@
       </p:sp>
       <p:sp>
         <p:nvSpPr>
-          <p:cNvPr id="135" name="Rectangle 134"/>
+          <p:cNvPr id="127" name="Rectangle 126"/>
           <p:cNvSpPr/>
           <p:nvPr/>
         </p:nvSpPr>
         <p:spPr>
           <a:xfrm>
-            <a:off x="7682885" y="4837084"/>
-            <a:ext cx="442762" cy="65562"/>
+            <a:off x="5992367" y="4837084"/>
+            <a:ext cx="565708" cy="65562"/>
           </a:xfrm>
           <a:prstGeom prst="rect">
             <a:avLst/>
@@ -15487,7 +15179,7 @@
       </p:sp>
       <p:sp>
         <p:nvSpPr>
-          <p:cNvPr id="136" name="TextBox 135"/>
+          <p:cNvPr id="128" name="TextBox 127"/>
           <p:cNvSpPr txBox="1"/>
           <p:nvPr/>
         </p:nvSpPr>
@@ -15522,7 +15214,7 @@
       </p:sp>
       <p:sp>
         <p:nvSpPr>
-          <p:cNvPr id="137" name="TextBox 136"/>
+          <p:cNvPr id="129" name="TextBox 128"/>
           <p:cNvSpPr txBox="1"/>
           <p:nvPr/>
         </p:nvSpPr>
@@ -15557,14 +15249,14 @@
       </p:sp>
       <p:sp>
         <p:nvSpPr>
-          <p:cNvPr id="138" name="Rectangle 137"/>
+          <p:cNvPr id="130" name="Rectangle 129"/>
           <p:cNvSpPr/>
           <p:nvPr/>
         </p:nvSpPr>
         <p:spPr>
           <a:xfrm>
-            <a:off x="7682885" y="4946355"/>
-            <a:ext cx="903812" cy="65562"/>
+            <a:off x="5992367" y="4946355"/>
+            <a:ext cx="1149705" cy="65562"/>
           </a:xfrm>
           <a:prstGeom prst="rect">
             <a:avLst/>
@@ -15587,7 +15279,7 @@
       </p:sp>
       <p:sp>
         <p:nvSpPr>
-          <p:cNvPr id="139" name="TextBox 138"/>
+          <p:cNvPr id="131" name="TextBox 130"/>
           <p:cNvSpPr txBox="1"/>
           <p:nvPr/>
         </p:nvSpPr>
@@ -15622,7 +15314,7 @@
       </p:sp>
       <p:sp>
         <p:nvSpPr>
-          <p:cNvPr id="140" name="TextBox 139"/>
+          <p:cNvPr id="132" name="TextBox 131"/>
           <p:cNvSpPr txBox="1"/>
           <p:nvPr/>
         </p:nvSpPr>
@@ -15657,14 +15349,14 @@
       </p:sp>
       <p:sp>
         <p:nvSpPr>
-          <p:cNvPr id="141" name="Rectangle 140"/>
+          <p:cNvPr id="133" name="Rectangle 132"/>
           <p:cNvSpPr/>
           <p:nvPr/>
         </p:nvSpPr>
         <p:spPr>
           <a:xfrm>
-            <a:off x="8143935" y="5055626"/>
-            <a:ext cx="903812" cy="65562"/>
+            <a:off x="6576364" y="5055626"/>
+            <a:ext cx="1149705" cy="65562"/>
           </a:xfrm>
           <a:prstGeom prst="rect">
             <a:avLst/>
@@ -15687,7 +15379,7 @@
       </p:sp>
       <p:sp>
         <p:nvSpPr>
-          <p:cNvPr id="142" name="TextBox 141"/>
+          <p:cNvPr id="134" name="TextBox 133"/>
           <p:cNvSpPr txBox="1"/>
           <p:nvPr/>
         </p:nvSpPr>
@@ -15722,7 +15414,7 @@
       </p:sp>
       <p:sp>
         <p:nvSpPr>
-          <p:cNvPr id="143" name="TextBox 142"/>
+          <p:cNvPr id="135" name="TextBox 134"/>
           <p:cNvSpPr txBox="1"/>
           <p:nvPr/>
         </p:nvSpPr>
@@ -15757,14 +15449,14 @@
       </p:sp>
       <p:sp>
         <p:nvSpPr>
-          <p:cNvPr id="144" name="Rectangle 143"/>
+          <p:cNvPr id="136" name="Rectangle 135"/>
           <p:cNvSpPr/>
           <p:nvPr/>
         </p:nvSpPr>
         <p:spPr>
           <a:xfrm>
-            <a:off x="6760784" y="5164896"/>
-            <a:ext cx="1825912" cy="65562"/>
+            <a:off x="4824374" y="5164896"/>
+            <a:ext cx="1733702" cy="65562"/>
           </a:xfrm>
           <a:prstGeom prst="rect">
             <a:avLst/>
@@ -15787,7 +15479,7 @@
       </p:sp>
       <p:sp>
         <p:nvSpPr>
-          <p:cNvPr id="145" name="TextBox 144"/>
+          <p:cNvPr id="137" name="TextBox 136"/>
           <p:cNvSpPr txBox="1"/>
           <p:nvPr/>
         </p:nvSpPr>
@@ -15822,7 +15514,7 @@
       </p:sp>
       <p:sp>
         <p:nvSpPr>
-          <p:cNvPr id="146" name="TextBox 145"/>
+          <p:cNvPr id="138" name="TextBox 137"/>
           <p:cNvSpPr txBox="1"/>
           <p:nvPr/>
         </p:nvSpPr>
@@ -15857,14 +15549,14 @@
       </p:sp>
       <p:sp>
         <p:nvSpPr>
-          <p:cNvPr id="147" name="Rectangle 146"/>
+          <p:cNvPr id="139" name="Rectangle 138"/>
           <p:cNvSpPr/>
           <p:nvPr/>
         </p:nvSpPr>
         <p:spPr>
           <a:xfrm>
-            <a:off x="8604985" y="5274167"/>
-            <a:ext cx="442762" cy="65562"/>
+            <a:off x="7160361" y="5274167"/>
+            <a:ext cx="565708" cy="65562"/>
           </a:xfrm>
           <a:prstGeom prst="rect">
             <a:avLst/>
@@ -15887,7 +15579,7 @@
       </p:sp>
       <p:sp>
         <p:nvSpPr>
-          <p:cNvPr id="148" name="TextBox 147"/>
+          <p:cNvPr id="140" name="TextBox 139"/>
           <p:cNvSpPr txBox="1"/>
           <p:nvPr/>
         </p:nvSpPr>
@@ -15922,7 +15614,7 @@
       </p:sp>
       <p:sp>
         <p:nvSpPr>
-          <p:cNvPr id="149" name="TextBox 148"/>
+          <p:cNvPr id="141" name="TextBox 140"/>
           <p:cNvSpPr txBox="1"/>
           <p:nvPr/>
         </p:nvSpPr>
@@ -15957,14 +15649,14 @@
       </p:sp>
       <p:sp>
         <p:nvSpPr>
-          <p:cNvPr id="150" name="Rectangle 149"/>
+          <p:cNvPr id="142" name="Rectangle 141"/>
           <p:cNvSpPr/>
           <p:nvPr/>
         </p:nvSpPr>
         <p:spPr>
           <a:xfrm>
-            <a:off x="9066035" y="5383438"/>
-            <a:ext cx="442762" cy="65562"/>
+            <a:off x="7160361" y="5383438"/>
+            <a:ext cx="565708" cy="65562"/>
           </a:xfrm>
           <a:prstGeom prst="rect">
             <a:avLst/>
@@ -15987,7 +15679,7 @@
       </p:sp>
       <p:cxnSp>
         <p:nvCxnSpPr>
-          <p:cNvPr id="151" name="Connector 150"/>
+          <p:cNvPr id="143" name="Connector 142"/>
           <p:cNvCxnSpPr/>
           <p:nvPr/>
         </p:nvCxnSpPr>
@@ -16022,7 +15714,7 @@
       </p:cxnSp>
       <p:sp>
         <p:nvSpPr>
-          <p:cNvPr id="152" name="TextBox 151"/>
+          <p:cNvPr id="144" name="TextBox 143"/>
           <p:cNvSpPr txBox="1"/>
           <p:nvPr/>
         </p:nvSpPr>
@@ -16057,7 +15749,7 @@
       </p:sp>
       <p:sp>
         <p:nvSpPr>
-          <p:cNvPr id="153" name="TextBox 152"/>
+          <p:cNvPr id="145" name="TextBox 144"/>
           <p:cNvSpPr txBox="1"/>
           <p:nvPr/>
         </p:nvSpPr>
@@ -16092,14 +15784,14 @@
       </p:sp>
       <p:sp>
         <p:nvSpPr>
-          <p:cNvPr id="154" name="Rectangle 153"/>
+          <p:cNvPr id="146" name="Rectangle 145"/>
           <p:cNvSpPr/>
           <p:nvPr/>
         </p:nvSpPr>
         <p:spPr>
           <a:xfrm>
-            <a:off x="9066035" y="5492709"/>
-            <a:ext cx="1364862" cy="65562"/>
+            <a:off x="7160361" y="5492709"/>
+            <a:ext cx="1149705" cy="65562"/>
           </a:xfrm>
           <a:prstGeom prst="rect">
             <a:avLst/>
@@ -16122,7 +15814,7 @@
       </p:sp>
       <p:sp>
         <p:nvSpPr>
-          <p:cNvPr id="155" name="TextBox 154"/>
+          <p:cNvPr id="147" name="TextBox 146"/>
           <p:cNvSpPr txBox="1"/>
           <p:nvPr/>
         </p:nvSpPr>
@@ -16157,7 +15849,7 @@
       </p:sp>
       <p:sp>
         <p:nvSpPr>
-          <p:cNvPr id="156" name="TextBox 155"/>
+          <p:cNvPr id="148" name="TextBox 147"/>
           <p:cNvSpPr txBox="1"/>
           <p:nvPr/>
         </p:nvSpPr>
@@ -16192,14 +15884,14 @@
       </p:sp>
       <p:sp>
         <p:nvSpPr>
-          <p:cNvPr id="157" name="Rectangle 156"/>
+          <p:cNvPr id="149" name="Rectangle 148"/>
           <p:cNvSpPr/>
           <p:nvPr/>
         </p:nvSpPr>
         <p:spPr>
           <a:xfrm>
-            <a:off x="9988135" y="5601980"/>
-            <a:ext cx="1364862" cy="65562"/>
+            <a:off x="7744358" y="5601980"/>
+            <a:ext cx="1733702" cy="65562"/>
           </a:xfrm>
           <a:prstGeom prst="rect">
             <a:avLst/>
@@ -16222,7 +15914,7 @@
       </p:sp>
       <p:sp>
         <p:nvSpPr>
-          <p:cNvPr id="158" name="TextBox 157"/>
+          <p:cNvPr id="150" name="TextBox 149"/>
           <p:cNvSpPr txBox="1"/>
           <p:nvPr/>
         </p:nvSpPr>
@@ -16257,7 +15949,7 @@
       </p:sp>
       <p:sp>
         <p:nvSpPr>
-          <p:cNvPr id="159" name="TextBox 158"/>
+          <p:cNvPr id="151" name="TextBox 150"/>
           <p:cNvSpPr txBox="1"/>
           <p:nvPr/>
         </p:nvSpPr>
@@ -16292,14 +15984,14 @@
       </p:sp>
       <p:sp>
         <p:nvSpPr>
-          <p:cNvPr id="160" name="Rectangle 159"/>
+          <p:cNvPr id="152" name="Rectangle 151"/>
           <p:cNvSpPr/>
           <p:nvPr/>
         </p:nvSpPr>
         <p:spPr>
           <a:xfrm>
-            <a:off x="9988135" y="5711250"/>
-            <a:ext cx="1364862" cy="65562"/>
+            <a:off x="7744358" y="5711250"/>
+            <a:ext cx="1733702" cy="65562"/>
           </a:xfrm>
           <a:prstGeom prst="rect">
             <a:avLst/>
@@ -16322,7 +16014,7 @@
       </p:sp>
       <p:sp>
         <p:nvSpPr>
-          <p:cNvPr id="161" name="TextBox 160"/>
+          <p:cNvPr id="153" name="TextBox 152"/>
           <p:cNvSpPr txBox="1"/>
           <p:nvPr/>
         </p:nvSpPr>
@@ -16357,7 +16049,7 @@
       </p:sp>
       <p:sp>
         <p:nvSpPr>
-          <p:cNvPr id="162" name="TextBox 161"/>
+          <p:cNvPr id="154" name="TextBox 153"/>
           <p:cNvSpPr txBox="1"/>
           <p:nvPr/>
         </p:nvSpPr>
@@ -16392,14 +16084,14 @@
       </p:sp>
       <p:sp>
         <p:nvSpPr>
-          <p:cNvPr id="163" name="Rectangle 162"/>
+          <p:cNvPr id="155" name="Rectangle 154"/>
           <p:cNvSpPr/>
           <p:nvPr/>
         </p:nvSpPr>
         <p:spPr>
           <a:xfrm>
-            <a:off x="9988135" y="5820521"/>
-            <a:ext cx="1364862" cy="65562"/>
+            <a:off x="7744358" y="5820521"/>
+            <a:ext cx="1733702" cy="65562"/>
           </a:xfrm>
           <a:prstGeom prst="rect">
             <a:avLst/>
@@ -16422,7 +16114,7 @@
       </p:sp>
       <p:sp>
         <p:nvSpPr>
-          <p:cNvPr id="164" name="TextBox 163"/>
+          <p:cNvPr id="156" name="TextBox 155"/>
           <p:cNvSpPr txBox="1"/>
           <p:nvPr/>
         </p:nvSpPr>
@@ -16457,7 +16149,7 @@
       </p:sp>
       <p:sp>
         <p:nvSpPr>
-          <p:cNvPr id="165" name="TextBox 164"/>
+          <p:cNvPr id="157" name="TextBox 156"/>
           <p:cNvSpPr txBox="1"/>
           <p:nvPr/>
         </p:nvSpPr>
@@ -16492,14 +16184,14 @@
       </p:sp>
       <p:sp>
         <p:nvSpPr>
-          <p:cNvPr id="166" name="Rectangle 165"/>
+          <p:cNvPr id="158" name="Rectangle 157"/>
           <p:cNvSpPr/>
           <p:nvPr/>
         </p:nvSpPr>
         <p:spPr>
           <a:xfrm>
-            <a:off x="10910235" y="5929792"/>
-            <a:ext cx="903812" cy="65562"/>
+            <a:off x="8912352" y="5929792"/>
+            <a:ext cx="1149705" cy="65562"/>
           </a:xfrm>
           <a:prstGeom prst="rect">
             <a:avLst/>
@@ -16522,7 +16214,7 @@
       </p:sp>
       <p:sp>
         <p:nvSpPr>
-          <p:cNvPr id="167" name="TextBox 166"/>
+          <p:cNvPr id="159" name="TextBox 158"/>
           <p:cNvSpPr txBox="1"/>
           <p:nvPr/>
         </p:nvSpPr>
@@ -16557,7 +16249,7 @@
       </p:sp>
       <p:sp>
         <p:nvSpPr>
-          <p:cNvPr id="168" name="TextBox 167"/>
+          <p:cNvPr id="160" name="TextBox 159"/>
           <p:cNvSpPr txBox="1"/>
           <p:nvPr/>
         </p:nvSpPr>
@@ -16592,14 +16284,14 @@
       </p:sp>
       <p:sp>
         <p:nvSpPr>
-          <p:cNvPr id="169" name="Rectangle 168"/>
+          <p:cNvPr id="161" name="Rectangle 160"/>
           <p:cNvSpPr/>
           <p:nvPr/>
         </p:nvSpPr>
         <p:spPr>
           <a:xfrm>
-            <a:off x="11371285" y="6039063"/>
-            <a:ext cx="442762" cy="65562"/>
+            <a:off x="9496348" y="6039063"/>
+            <a:ext cx="565708" cy="65562"/>
           </a:xfrm>
           <a:prstGeom prst="rect">
             <a:avLst/>
@@ -16622,13 +16314,13 @@
       </p:sp>
       <p:cxnSp>
         <p:nvCxnSpPr>
-          <p:cNvPr id="170" name="Connector 169"/>
+          <p:cNvPr id="162" name="Connector 161"/>
           <p:cNvCxnSpPr/>
           <p:nvPr/>
         </p:nvCxnSpPr>
         <p:spPr>
           <a:xfrm>
-            <a:off x="9517941" y="1371600"/>
+            <a:off x="7735214" y="1371600"/>
             <a:ext cx="0" cy="4754880"/>
           </a:xfrm>
           <a:prstGeom prst="line">
@@ -16658,13 +16350,13 @@
       </p:cxnSp>
       <p:sp>
         <p:nvSpPr>
-          <p:cNvPr id="171" name="TextBox 170"/>
-          <p:cNvSpPr txBox="1"/>
-          <p:nvPr/>
-        </p:nvSpPr>
-        <p:spPr>
-          <a:xfrm>
-            <a:off x="8054901" y="1143000"/>
+          <p:cNvPr id="163" name="TextBox 162"/>
+          <p:cNvSpPr txBox="1"/>
+          <p:nvPr/>
+        </p:nvSpPr>
+        <p:spPr>
+          <a:xfrm>
+            <a:off x="6272174" y="1143000"/>
             <a:ext cx="1417320" cy="201168"/>
           </a:xfrm>
           <a:prstGeom prst="rect">
@@ -16691,16 +16383,51 @@
           </a:p>
         </p:txBody>
       </p:sp>
-      <p:sp>
-        <p:nvSpPr>
-          <p:cNvPr id="172" name="TextBox 171"/>
-          <p:cNvSpPr txBox="1"/>
-          <p:nvPr/>
-        </p:nvSpPr>
-        <p:spPr>
-          <a:xfrm>
-            <a:off x="9537192" y="1143000"/>
-            <a:ext cx="2286000" cy="201168"/>
+      <p:cxnSp>
+        <p:nvCxnSpPr>
+          <p:cNvPr id="164" name="Connector 163"/>
+          <p:cNvCxnSpPr/>
+          <p:nvPr/>
+        </p:nvCxnSpPr>
+        <p:spPr>
+          <a:xfrm>
+            <a:off x="10071201" y="1371600"/>
+            <a:ext cx="0" cy="4754880"/>
+          </a:xfrm>
+          <a:prstGeom prst="line">
+            <a:avLst/>
+          </a:prstGeom>
+          <a:ln w="19050">
+            <a:solidFill>
+              <a:srgbClr val="C26A0A"/>
+            </a:solidFill>
+          </a:ln>
+        </p:spPr>
+        <p:style>
+          <a:lnRef idx="2">
+            <a:schemeClr val="accent1"/>
+          </a:lnRef>
+          <a:fillRef idx="0">
+            <a:schemeClr val="accent1"/>
+          </a:fillRef>
+          <a:effectRef idx="1">
+            <a:schemeClr val="accent1"/>
+          </a:effectRef>
+          <a:fontRef idx="minor">
+            <a:schemeClr val="tx1"/>
+          </a:fontRef>
+        </p:style>
+      </p:cxnSp>
+      <p:sp>
+        <p:nvSpPr>
+          <p:cNvPr id="165" name="TextBox 164"/>
+          <p:cNvSpPr txBox="1"/>
+          <p:nvPr/>
+        </p:nvSpPr>
+        <p:spPr>
+          <a:xfrm>
+            <a:off x="7693761" y="1143000"/>
+            <a:ext cx="2331720" cy="201168"/>
           </a:xfrm>
           <a:prstGeom prst="rect">
             <a:avLst/>
@@ -16721,14 +16448,49 @@
                 </a:solidFill>
                 <a:latin typeface="Calibri"/>
               </a:rPr>
-              <a:t>Target indikatif pipeline (M7.5)</a:t>
-            </a:r>
-          </a:p>
-        </p:txBody>
-      </p:sp>
-      <p:sp>
-        <p:nvSpPr>
-          <p:cNvPr id="173" name="Rectangle 172"/>
+              <a:t>Akhir TAF · target pipeline (M7.5)</a:t>
+            </a:r>
+          </a:p>
+        </p:txBody>
+      </p:sp>
+      <p:sp>
+        <p:nvSpPr>
+          <p:cNvPr id="166" name="TextBox 165"/>
+          <p:cNvSpPr txBox="1"/>
+          <p:nvPr/>
+        </p:nvSpPr>
+        <p:spPr>
+          <a:xfrm>
+            <a:off x="10116921" y="1143000"/>
+            <a:ext cx="1828800" cy="201168"/>
+          </a:xfrm>
+          <a:prstGeom prst="rect">
+            <a:avLst/>
+          </a:prstGeom>
+          <a:noFill/>
+        </p:spPr>
+        <p:txBody>
+          <a:bodyPr wrap="square" lIns="18288" rIns="18288" tIns="9144" bIns="9144" anchor="t">
+            <a:spAutoFit/>
+          </a:bodyPr>
+          <a:lstStyle/>
+          <a:p>
+            <a:pPr algn="l"/>
+            <a:r>
+              <a:rPr sz="700" b="0" i="1">
+                <a:solidFill>
+                  <a:srgbClr val="C26A0A"/>
+                </a:solidFill>
+                <a:latin typeface="Calibri"/>
+              </a:rPr>
+              <a:t>Buffer review di luar TAF</a:t>
+            </a:r>
+          </a:p>
+        </p:txBody>
+      </p:sp>
+      <p:sp>
+        <p:nvSpPr>
+          <p:cNvPr id="167" name="Rectangle 166"/>
           <p:cNvSpPr/>
           <p:nvPr/>
         </p:nvSpPr>
@@ -16758,7 +16520,7 @@
       </p:sp>
       <p:sp>
         <p:nvSpPr>
-          <p:cNvPr id="174" name="TextBox 173"/>
+          <p:cNvPr id="168" name="TextBox 167"/>
           <p:cNvSpPr txBox="1"/>
           <p:nvPr/>
         </p:nvSpPr>
@@ -16793,7 +16555,7 @@
       </p:sp>
       <p:sp>
         <p:nvSpPr>
-          <p:cNvPr id="175" name="Rectangle 174"/>
+          <p:cNvPr id="169" name="Rectangle 168"/>
           <p:cNvSpPr/>
           <p:nvPr/>
         </p:nvSpPr>
@@ -16823,7 +16585,7 @@
       </p:sp>
       <p:sp>
         <p:nvSpPr>
-          <p:cNvPr id="176" name="TextBox 175"/>
+          <p:cNvPr id="170" name="TextBox 169"/>
           <p:cNvSpPr txBox="1"/>
           <p:nvPr/>
         </p:nvSpPr>
@@ -16858,7 +16620,7 @@
       </p:sp>
       <p:sp>
         <p:nvSpPr>
-          <p:cNvPr id="177" name="Rectangle 176"/>
+          <p:cNvPr id="171" name="Rectangle 170"/>
           <p:cNvSpPr/>
           <p:nvPr/>
         </p:nvSpPr>
@@ -16888,7 +16650,7 @@
       </p:sp>
       <p:sp>
         <p:nvSpPr>
-          <p:cNvPr id="178" name="TextBox 177"/>
+          <p:cNvPr id="172" name="TextBox 171"/>
           <p:cNvSpPr txBox="1"/>
           <p:nvPr/>
         </p:nvSpPr>
@@ -16923,7 +16685,7 @@
       </p:sp>
       <p:sp>
         <p:nvSpPr>
-          <p:cNvPr id="179" name="TextBox 178"/>
+          <p:cNvPr id="173" name="TextBox 172"/>
           <p:cNvSpPr txBox="1"/>
           <p:nvPr/>
         </p:nvSpPr>
@@ -16951,14 +16713,14 @@
                 </a:solidFill>
                 <a:latin typeface="Calibri"/>
               </a:rPr>
-              <a:t>STEP 2 jangka panjang: M8 2028–29 · M9 2029–30 · M10 2030→ · M11 ≤5 th pasca-validasi · M12 paralel</a:t>
-            </a:r>
-          </a:p>
-        </p:txBody>
-      </p:sp>
-      <p:sp>
-        <p:nvSpPr>
-          <p:cNvPr id="180" name="TextBox 179"/>
+              <a:t>STEP 2 jangka panjang: M8 2027–29 · M9 2029–30 · M10 2030→ · M11 ≤5 th pasca-validasi · M12 paralel</a:t>
+            </a:r>
+          </a:p>
+        </p:txBody>
+      </p:sp>
+      <p:sp>
+        <p:nvSpPr>
+          <p:cNvPr id="174" name="TextBox 173"/>
           <p:cNvSpPr txBox="1"/>
           <p:nvPr/>
         </p:nvSpPr>
@@ -16986,7 +16748,7 @@
                 </a:solidFill>
                 <a:latin typeface="Calibri"/>
               </a:rPr>
-              <a:t>Bulan 1 = Oktober 2026. Review PIN: awal ±6 minggu; tanggapan CAR/NIR ±4 minggu; revisi wajib ≤6 bulan, maks. 3 putaran (Procedures Manual V3.9 §2.2, §9).</a:t>
+              <a:t>Bulan 1 = Oktober 2026; TAF berakhir bulan 12 (Sep 2027). Review PIN: awal ±6 minggu; tanggapan CAR/NIR ±4 minggu; revisi wajib ≤6 bulan, maks. 3 putaran (Procedures Manual V3.9 §2.2, §9).</a:t>
             </a:r>
           </a:p>
         </p:txBody>

</xml_diff>